<commit_message>
sparkasse-dueren: Deck-Update auf 30-Tage-Zeitraum + Begruendungen
- Alle Zahlen auf Peec-Default 04.07.-03.08.2026 (30 Tage, 61 Chats)
  umgestellt, um mit Kunden-UI-Sicht zu matchen
- Commerzbank (Sentiment 73) explizit im Sentiment-Caveat auf Folie 2
- ChatGPT-Aussage "groesster Hebel" datenbelegt (57 PP Delta,
  alle Wettbewerber 0 %)
- Volksbank-AIO-Wert korrigiert (21,1 % in 30d)
- Top-Quellen auf Folie 4 neu (sparkasse.de bundesweit dazu)

Co-Authored-By: Claude Opus 4.7 <noreply@anthropic.com>
Claude-Session: https://claude.ai/code/session_019JdfnJd2Mr6vK4FK3ePtt7
</commit_message>
<xml_diff>
--- a/kunden/sparkasse-dueren/decks/sparkasse_dueren_pitch.pptx
+++ b/kunden/sparkasse-dueren/decks/sparkasse_dueren_pitch.pptx
@@ -181,10 +181,10 @@
                     <c:v>Volksbank Euskirchen</c:v>
                   </c:pt>
                   <c:pt idx="2">
-                    <c:v>Deutsche Bank Düren</c:v>
+                    <c:v>Commerzbank Düren</c:v>
                   </c:pt>
                   <c:pt idx="3">
-                    <c:v>Commerzbank Düren</c:v>
+                    <c:v>Deutsche Bank Düren</c:v>
                   </c:pt>
                 </c:lvl>
               </c:multiLvlStrCache>
@@ -197,16 +197,16 @@
                 <c:formatCode>General</c:formatCode>
                 <c:ptCount val="4"/>
                 <c:pt idx="0">
-                  <c:v>52.8</c:v>
+                  <c:v>59</c:v>
                 </c:pt>
                 <c:pt idx="1">
-                  <c:v>15.1</c:v>
+                  <c:v>13.1</c:v>
                 </c:pt>
                 <c:pt idx="2">
-                  <c:v>3.8</c:v>
+                  <c:v>3.3</c:v>
                 </c:pt>
                 <c:pt idx="3">
-                  <c:v>1.9</c:v>
+                  <c:v>3.3</c:v>
                 </c:pt>
               </c:numCache>
             </c:numRef>
@@ -436,16 +436,16 @@
                     <c:v>dueren.de</c:v>
                   </c:pt>
                   <c:pt idx="3">
-                    <c:v>verbraucherzentrale.de</c:v>
+                    <c:v>sparkasse.de</c:v>
                   </c:pt>
                   <c:pt idx="4">
-                    <c:v>deutsche-rentenversicherung.de</c:v>
+                    <c:v>verbraucherzentrale.de</c:v>
                   </c:pt>
                   <c:pt idx="5">
                     <c:v>youtube.com</c:v>
                   </c:pt>
                   <c:pt idx="6">
-                    <c:v>kfw.de</c:v>
+                    <c:v>deutsche-rentenversicherung.de</c:v>
                   </c:pt>
                 </c:lvl>
               </c:multiLvlStrCache>
@@ -458,25 +458,25 @@
                 <c:formatCode>General</c:formatCode>
                 <c:ptCount val="7"/>
                 <c:pt idx="0">
-                  <c:v>30.2</c:v>
+                  <c:v>34.4</c:v>
                 </c:pt>
                 <c:pt idx="1">
-                  <c:v>28.3</c:v>
+                  <c:v>24.6</c:v>
                 </c:pt>
                 <c:pt idx="2">
-                  <c:v>20.8</c:v>
+                  <c:v>18</c:v>
                 </c:pt>
                 <c:pt idx="3">
-                  <c:v>13.2</c:v>
+                  <c:v>14.7</c:v>
                 </c:pt>
                 <c:pt idx="4">
-                  <c:v>11.3</c:v>
+                  <c:v>11.5</c:v>
                 </c:pt>
                 <c:pt idx="5">
-                  <c:v>11.3</c:v>
+                  <c:v>9.8</c:v>
                 </c:pt>
                 <c:pt idx="6">
-                  <c:v>3.8</c:v>
+                  <c:v>9.8</c:v>
                 </c:pt>
               </c:numCache>
             </c:numRef>
@@ -557,7 +557,7 @@
         <c:axId val="2094734552"/>
         <c:scaling>
           <c:orientation val="minMax"/>
-          <c:max val="35"/>
+          <c:max val="40"/>
           <c:min val="0"/>
         </c:scaling>
         <c:delete val="0"/>
@@ -2018,7 +2018,7 @@
                 <a:ea typeface="Calibri" pitchFamily="34" charset="-122"/>
                 <a:cs typeface="Calibri" pitchFamily="34" charset="-120"/>
               </a:rPr>
-              <a:t>73,7 %</a:t>
+              <a:t>78,1 %</a:t>
             </a:r>
             <a:endParaRPr lang="en-US" sz="5600" dirty="0"/>
           </a:p>
@@ -2032,8 +2032,8 @@
         </p:nvSpPr>
         <p:spPr>
           <a:xfrm>
-            <a:off x="700888" y="3657600"/>
-            <a:ext cx="3200400" cy="594360"/>
+            <a:off x="700888" y="3611880"/>
+            <a:ext cx="3200400" cy="502920"/>
           </a:xfrm>
           <a:prstGeom prst="rect">
             <a:avLst/>
@@ -2046,10 +2046,13 @@
           <a:lstStyle/>
           <a:p>
             <a:pPr indent="0" marL="0">
-              <a:buNone/>
-            </a:pPr>
-            <a:r>
-              <a:rPr lang="en-US" sz="1300" b="1" dirty="0">
+              <a:lnSpc>
+                <a:spcPct val="115000"/>
+              </a:lnSpc>
+              <a:buNone/>
+            </a:pPr>
+            <a:r>
+              <a:rPr lang="en-US" sz="1250" b="1" dirty="0">
                 <a:solidFill>
                   <a:srgbClr val="0A1117"/>
                 </a:solidFill>
@@ -2059,7 +2062,7 @@
               </a:rPr>
               <a:t>Share of Voice der Sparkasse Düren</a:t>
             </a:r>
-            <a:endParaRPr lang="en-US" sz="1300" dirty="0"/>
+            <a:endParaRPr lang="en-US" sz="1250" dirty="0"/>
           </a:p>
         </p:txBody>
       </p:sp>
@@ -2071,8 +2074,8 @@
         </p:nvSpPr>
         <p:spPr>
           <a:xfrm>
-            <a:off x="700888" y="4251960"/>
-            <a:ext cx="3200400" cy="502920"/>
+            <a:off x="700888" y="4114800"/>
+            <a:ext cx="3200400" cy="640080"/>
           </a:xfrm>
           <a:prstGeom prst="rect">
             <a:avLst/>
@@ -2085,10 +2088,13 @@
           <a:lstStyle/>
           <a:p>
             <a:pPr indent="0" marL="0">
-              <a:buNone/>
-            </a:pPr>
-            <a:r>
-              <a:rPr lang="en-US" sz="1050" dirty="0">
+              <a:lnSpc>
+                <a:spcPct val="120000"/>
+              </a:lnSpc>
+              <a:buNone/>
+            </a:pPr>
+            <a:r>
+              <a:rPr lang="en-US" sz="1000" dirty="0">
                 <a:solidFill>
                   <a:srgbClr val="737F86"/>
                 </a:solidFill>
@@ -2096,9 +2102,9 @@
                 <a:ea typeface="Calibri" pitchFamily="34" charset="-122"/>
                 <a:cs typeface="Calibri" pitchFamily="34" charset="-120"/>
               </a:rPr>
-              <a:t>in allen regional-relevanten KI-Antworten (n = 53 Chats).</a:t>
-            </a:r>
-            <a:endParaRPr lang="en-US" sz="1050" dirty="0"/>
+              <a:t>in allen regional-relevanten KI-Antworten der letzten 30 Tage (n = 61 Chats).</a:t>
+            </a:r>
+            <a:endParaRPr lang="en-US" sz="1000" dirty="0"/>
           </a:p>
         </p:txBody>
       </p:sp>
@@ -2201,8 +2207,8 @@
         </p:nvSpPr>
         <p:spPr>
           <a:xfrm>
-            <a:off x="4495648" y="3657600"/>
-            <a:ext cx="3200400" cy="594360"/>
+            <a:off x="4495648" y="3611880"/>
+            <a:ext cx="3200400" cy="502920"/>
           </a:xfrm>
           <a:prstGeom prst="rect">
             <a:avLst/>
@@ -2215,10 +2221,13 @@
           <a:lstStyle/>
           <a:p>
             <a:pPr indent="0" marL="0">
-              <a:buNone/>
-            </a:pPr>
-            <a:r>
-              <a:rPr lang="en-US" sz="1300" b="1" dirty="0">
+              <a:lnSpc>
+                <a:spcPct val="115000"/>
+              </a:lnSpc>
+              <a:buNone/>
+            </a:pPr>
+            <a:r>
+              <a:rPr lang="en-US" sz="1250" b="1" dirty="0">
                 <a:solidFill>
                   <a:srgbClr val="0A1117"/>
                 </a:solidFill>
@@ -2228,7 +2237,7 @@
               </a:rPr>
               <a:t>Sichtbarkeit bei Rentenberatung &amp; Erbe/Geldanlage</a:t>
             </a:r>
-            <a:endParaRPr lang="en-US" sz="1300" dirty="0"/>
+            <a:endParaRPr lang="en-US" sz="1250" dirty="0"/>
           </a:p>
         </p:txBody>
       </p:sp>
@@ -2240,8 +2249,8 @@
         </p:nvSpPr>
         <p:spPr>
           <a:xfrm>
-            <a:off x="4495648" y="4251960"/>
-            <a:ext cx="3200400" cy="502920"/>
+            <a:off x="4495648" y="4114800"/>
+            <a:ext cx="3200400" cy="640080"/>
           </a:xfrm>
           <a:prstGeom prst="rect">
             <a:avLst/>
@@ -2254,10 +2263,13 @@
           <a:lstStyle/>
           <a:p>
             <a:pPr indent="0" marL="0">
-              <a:buNone/>
-            </a:pPr>
-            <a:r>
-              <a:rPr lang="en-US" sz="1050" dirty="0">
+              <a:lnSpc>
+                <a:spcPct val="120000"/>
+              </a:lnSpc>
+              <a:buNone/>
+            </a:pPr>
+            <a:r>
+              <a:rPr lang="en-US" sz="1000" dirty="0">
                 <a:solidFill>
                   <a:srgbClr val="737F86"/>
                 </a:solidFill>
@@ -2267,7 +2279,7 @@
               </a:rPr>
               <a:t>Zwei umsatzstarke Beratungsthemen laufen komplett an Ihnen vorbei.</a:t>
             </a:r>
-            <a:endParaRPr lang="en-US" sz="1050" dirty="0"/>
+            <a:endParaRPr lang="en-US" sz="1000" dirty="0"/>
           </a:p>
         </p:txBody>
       </p:sp>
@@ -2356,7 +2368,7 @@
                 <a:ea typeface="Calibri" pitchFamily="34" charset="-122"/>
                 <a:cs typeface="Calibri" pitchFamily="34" charset="-120"/>
               </a:rPr>
-              <a:t>33 %</a:t>
+              <a:t>42,9 %</a:t>
             </a:r>
             <a:endParaRPr lang="en-US" sz="5600" dirty="0"/>
           </a:p>
@@ -2370,8 +2382,8 @@
         </p:nvSpPr>
         <p:spPr>
           <a:xfrm>
-            <a:off x="8290408" y="3657600"/>
-            <a:ext cx="3200400" cy="594360"/>
+            <a:off x="8290408" y="3611880"/>
+            <a:ext cx="3200400" cy="502920"/>
           </a:xfrm>
           <a:prstGeom prst="rect">
             <a:avLst/>
@@ -2384,10 +2396,13 @@
           <a:lstStyle/>
           <a:p>
             <a:pPr indent="0" marL="0">
-              <a:buNone/>
-            </a:pPr>
-            <a:r>
-              <a:rPr lang="en-US" sz="1300" b="1" dirty="0">
+              <a:lnSpc>
+                <a:spcPct val="115000"/>
+              </a:lnSpc>
+              <a:buNone/>
+            </a:pPr>
+            <a:r>
+              <a:rPr lang="en-US" sz="1250" b="1" dirty="0">
                 <a:solidFill>
                   <a:srgbClr val="0A1117"/>
                 </a:solidFill>
@@ -2395,9 +2410,9 @@
                 <a:ea typeface="Calibri" pitchFamily="34" charset="-122"/>
                 <a:cs typeface="Calibri" pitchFamily="34" charset="-120"/>
               </a:rPr>
-              <a:t>Sichtbarkeit in ChatGPT</a:t>
-            </a:r>
-            <a:endParaRPr lang="en-US" sz="1300" dirty="0"/>
+              <a:t>Sichtbarkeit in ChatGPT – größter Wachstumshebel</a:t>
+            </a:r>
+            <a:endParaRPr lang="en-US" sz="1250" dirty="0"/>
           </a:p>
         </p:txBody>
       </p:sp>
@@ -2409,8 +2424,8 @@
         </p:nvSpPr>
         <p:spPr>
           <a:xfrm>
-            <a:off x="8290408" y="4251960"/>
-            <a:ext cx="3200400" cy="502920"/>
+            <a:off x="8290408" y="4114800"/>
+            <a:ext cx="3200400" cy="640080"/>
           </a:xfrm>
           <a:prstGeom prst="rect">
             <a:avLst/>
@@ -2423,10 +2438,13 @@
           <a:lstStyle/>
           <a:p>
             <a:pPr indent="0" marL="0">
-              <a:buNone/>
-            </a:pPr>
-            <a:r>
-              <a:rPr lang="en-US" sz="1050" dirty="0">
+              <a:lnSpc>
+                <a:spcPct val="120000"/>
+              </a:lnSpc>
+              <a:buNone/>
+            </a:pPr>
+            <a:r>
+              <a:rPr lang="en-US" sz="1000" dirty="0">
                 <a:solidFill>
                   <a:srgbClr val="737F86"/>
                 </a:solidFill>
@@ -2434,9 +2452,9 @@
                 <a:ea typeface="Calibri" pitchFamily="34" charset="-122"/>
                 <a:cs typeface="Calibri" pitchFamily="34" charset="-120"/>
               </a:rPr>
-              <a:t>2 von 3 Antworten nennen Sie dort NICHT – das ist Ihr größter Hebel.</a:t>
-            </a:r>
-            <a:endParaRPr lang="en-US" sz="1050" dirty="0"/>
+              <a:t>Alle Wettbewerber dort bei 0 % → Sie besetzen den Kanal exklusiv, haben aber 57 PP Delta zum Maximum.</a:t>
+            </a:r>
+            <a:endParaRPr lang="en-US" sz="1000" dirty="0"/>
           </a:p>
         </p:txBody>
       </p:sp>
@@ -2591,7 +2609,7 @@
                 <a:ea typeface="Calibri" pitchFamily="34" charset="-122"/>
                 <a:cs typeface="Calibri" pitchFamily="34" charset="-120"/>
               </a:rPr>
-              <a:t>eology GmbH  ·  KI-Sichtbarkeit Sparkasse Düren  ·  Peec AI Monitoring 23.07.–03.08.2026</a:t>
+              <a:t>eology GmbH  ·  KI-Sichtbarkeit Sparkasse Düren  ·  Peec AI Monitoring 04.07.–03.08.2026 (30 Tage, n = 61 Chats)</a:t>
             </a:r>
             <a:endParaRPr lang="en-US" sz="900" dirty="0"/>
           </a:p>
@@ -2996,7 +3014,7 @@
                 <a:ea typeface="Calibri" pitchFamily="34" charset="-122"/>
                 <a:cs typeface="Calibri" pitchFamily="34" charset="-120"/>
               </a:rPr>
-              <a:t>Bei „Konto im Kreis Düren eröffnen“ bereits 66,7 % Sichtbarkeit – in Google AI Overview schon 23,5 % über alle Prompts hinweg.</a:t>
+              <a:t>Bei „Konto im Kreis Düren eröffnen“ bereits 66,7 % Sichtbarkeit; in Google AI Overview über alle Prompts hinweg 21,1 % (Sie: 63,2 %). Belegt: aktive Konkurrenz um Ihre kaufentscheidenden Kundenfragen.</a:t>
             </a:r>
             <a:endParaRPr lang="en-US" sz="1050" dirty="0"/>
           </a:p>
@@ -3146,7 +3164,7 @@
                 <a:ea typeface="Calibri" pitchFamily="34" charset="-122"/>
                 <a:cs typeface="Calibri" pitchFamily="34" charset="-120"/>
               </a:rPr>
-              <a:t>Sentiment (0–100) misst, wie positiv KI-Systeme über eine Marke sprechen; Normalbereich 65–85. Höhere Werte einzelner Wettbewerber (Deutsche Bank Düren: 56) basieren auf nur 1 Nennung und sind nicht belastbar. Bei Ihnen sind 42 Mentions repräsentativ – und optimierbar.</a:t>
+              <a:t>Sentiment (0–100) misst, wie positiv KI-Systeme über eine Marke sprechen; Normalbereich 65–85. Höhere Wettbewerbswerte (Commerzbank 73, Deutsche Bank 56) basieren auf nur 1 auswertbaren Nennung – statistisch nicht belastbar. Bei Ihnen sind 45 Bewertungen repräsentativ und optimierbar.</a:t>
             </a:r>
             <a:endParaRPr lang="en-US" sz="1050" dirty="0"/>
           </a:p>
@@ -3254,7 +3272,7 @@
                 <a:ea typeface="Calibri" pitchFamily="34" charset="-122"/>
                 <a:cs typeface="Calibri" pitchFamily="34" charset="-120"/>
               </a:rPr>
-              <a:t>ChatGPT: Sie sind exklusiv – aber nur in jeder dritten Antwort.</a:t>
+              <a:t>ChatGPT ist Ihr größter Wachstumshebel.</a:t>
             </a:r>
             <a:endParaRPr lang="en-US" sz="1500" dirty="0"/>
           </a:p>
@@ -3296,7 +3314,7 @@
                 <a:ea typeface="Calibri" pitchFamily="34" charset="-122"/>
                 <a:cs typeface="Calibri" pitchFamily="34" charset="-120"/>
               </a:rPr>
-              <a:t>Bei den 6 getrackten Kundenfragen sind Sie die einzige regionale Bank, die ChatGPT nennt (33,3 % Visibility). Kein Wettbewerber ist dort sichtbar – der Kanal gehört Ihnen, die restlichen zwei Drittel der Antworten sind Ausbau-Potenzial.</a:t>
+              <a:t>42,9 % Sichtbarkeit bei Ihnen – alle drei Wettbewerber bei 0 %. Damit haben Sie hier das größte Delta zum Maximum (57 PP nach oben, Gemini nur 29, AIO nur 37) und den einzigen KI-Kanal, in dem Sie exklusiv sind.</a:t>
             </a:r>
             <a:endParaRPr lang="en-US" sz="1050" dirty="0"/>
           </a:p>
@@ -3404,7 +3422,7 @@
                 <a:ea typeface="Calibri" pitchFamily="34" charset="-122"/>
                 <a:cs typeface="Calibri" pitchFamily="34" charset="-120"/>
               </a:rPr>
-              <a:t>Lokale Institutionen dominieren die Quellen.</a:t>
+              <a:t>Lokale Institutionen dominieren die Zitat-Basis.</a:t>
             </a:r>
             <a:endParaRPr lang="en-US" sz="1500" dirty="0"/>
           </a:p>
@@ -3446,7 +3464,7 @@
                 <a:ea typeface="Calibri" pitchFamily="34" charset="-122"/>
                 <a:cs typeface="Calibri" pitchFamily="34" charset="-120"/>
               </a:rPr>
-              <a:t>kreis-dueren.de, dueren.de, Verbraucherzentrale, KfW &amp; Rentenversicherung stellen die Zitat-Basis. Gezielte PR- &amp; Kooperations-Arbeit bringt Sie dort hinein.</a:t>
+              <a:t>kreis-dueren.de (28 Zitierungen), dueren.de (14), Verbraucherzentrale (15), Deutsche Rentenversicherung (12) und KfW (9) stellen die Quellen der KI. Gezielte PR- &amp; Kooperations-Arbeit macht Sie dort zitierfähig.</a:t>
             </a:r>
             <a:endParaRPr lang="en-US" sz="1050" dirty="0"/>
           </a:p>
@@ -3485,7 +3503,7 @@
                 <a:ea typeface="Calibri" pitchFamily="34" charset="-122"/>
                 <a:cs typeface="Calibri" pitchFamily="34" charset="-120"/>
               </a:rPr>
-              <a:t>eology GmbH  ·  KI-Sichtbarkeit Sparkasse Düren  ·  Peec AI Monitoring 23.07.–03.08.2026</a:t>
+              <a:t>eology GmbH  ·  KI-Sichtbarkeit Sparkasse Düren  ·  Peec AI Monitoring 04.07.–03.08.2026 (30 Tage, n = 61 Chats)</a:t>
             </a:r>
             <a:endParaRPr lang="en-US" sz="900" dirty="0"/>
           </a:p>
@@ -4025,7 +4043,7 @@
                 <a:ea typeface="Calibri" pitchFamily="34" charset="-122"/>
                 <a:cs typeface="Calibri" pitchFamily="34" charset="-120"/>
               </a:rPr>
-              <a:t>66.7 %</a:t>
+              <a:t>71.4 %</a:t>
             </a:r>
             <a:endParaRPr lang="en-US" sz="2000" dirty="0"/>
           </a:p>
@@ -4097,13 +4115,13 @@
             <a:r>
               <a:rPr lang="en-US" sz="2000" b="1" dirty="0">
                 <a:solidFill>
-                  <a:srgbClr val="FF6B4A"/>
-                </a:solidFill>
-                <a:latin typeface="Calibri" pitchFamily="34" charset="0"/>
-                <a:ea typeface="Calibri" pitchFamily="34" charset="-122"/>
-                <a:cs typeface="Calibri" pitchFamily="34" charset="-120"/>
-              </a:rPr>
-              <a:t>22.2 %</a:t>
+                  <a:srgbClr val="737F86"/>
+                </a:solidFill>
+                <a:latin typeface="Calibri" pitchFamily="34" charset="0"/>
+                <a:ea typeface="Calibri" pitchFamily="34" charset="-122"/>
+                <a:cs typeface="Calibri" pitchFamily="34" charset="-120"/>
+              </a:rPr>
+              <a:t>19.0 %</a:t>
             </a:r>
             <a:endParaRPr lang="en-US" sz="2000" dirty="0"/>
           </a:p>
@@ -4286,7 +4304,7 @@
                 <a:ea typeface="Calibri" pitchFamily="34" charset="-122"/>
                 <a:cs typeface="Calibri" pitchFamily="34" charset="-120"/>
               </a:rPr>
-              <a:t>58.8 %</a:t>
+              <a:t>63.2 %</a:t>
             </a:r>
             <a:endParaRPr lang="en-US" sz="2000" dirty="0"/>
           </a:p>
@@ -4364,7 +4382,7 @@
                 <a:ea typeface="Calibri" pitchFamily="34" charset="-122"/>
                 <a:cs typeface="Calibri" pitchFamily="34" charset="-120"/>
               </a:rPr>
-              <a:t>23.5 %</a:t>
+              <a:t>21.1 %</a:t>
             </a:r>
             <a:endParaRPr lang="en-US" sz="2000" dirty="0"/>
           </a:p>
@@ -4547,7 +4565,7 @@
                 <a:ea typeface="Calibri" pitchFamily="34" charset="-122"/>
                 <a:cs typeface="Calibri" pitchFamily="34" charset="-120"/>
               </a:rPr>
-              <a:t>33.3 %</a:t>
+              <a:t>42.9 %</a:t>
             </a:r>
             <a:endParaRPr lang="en-US" sz="2000" dirty="0"/>
           </a:p>
@@ -4774,7 +4792,7 @@
                 <a:ea typeface="Calibri" pitchFamily="34" charset="-122"/>
                 <a:cs typeface="Calibri" pitchFamily="34" charset="-120"/>
               </a:rPr>
-              <a:t>Er läuft direkt in der Google-Suche und ist mit Google Maps / Local integriert – 19 % der Peec-Antworten in diesem Projekt zeigen Map-Ergebnisse. </a:t>
+              <a:t>Er läuft direkt in der Google-Suche und ist mit Google Maps / Local integriert – 21,3 % der Peec-Antworten in diesem Projekt zeigen Map-Ergebnisse. </a:t>
             </a:r>
             <a:pPr indent="0" marL="0">
               <a:lnSpc>
@@ -4791,7 +4809,7 @@
                 <a:ea typeface="Calibri" pitchFamily="34" charset="-122"/>
                 <a:cs typeface="Calibri" pitchFamily="34" charset="-120"/>
               </a:rPr>
-              <a:t>Genau dort holt Volksbank Euskirchen bereits 23,5 % Sichtbarkeit auf – vor Ihrer Haustür.</a:t>
+              <a:t>Genau dort holt Volksbank Euskirchen bereits 21,1 % Sichtbarkeit auf – vor Ihrer Haustür.</a:t>
             </a:r>
             <a:endParaRPr lang="en-US" sz="1100" dirty="0"/>
           </a:p>
@@ -4830,7 +4848,7 @@
                 <a:ea typeface="Calibri" pitchFamily="34" charset="-122"/>
                 <a:cs typeface="Calibri" pitchFamily="34" charset="-120"/>
               </a:rPr>
-              <a:t>eology GmbH  ·  KI-Sichtbarkeit Sparkasse Düren  ·  Peec AI Monitoring 23.07.–03.08.2026</a:t>
+              <a:t>eology GmbH  ·  KI-Sichtbarkeit Sparkasse Düren  ·  Peec AI Monitoring 04.07.–03.08.2026 (30 Tage, n = 61 Chats)</a:t>
             </a:r>
             <a:endParaRPr lang="en-US" sz="900" dirty="0"/>
           </a:p>
@@ -6063,7 +6081,7 @@
                 <a:ea typeface="Calibri" pitchFamily="34" charset="-122"/>
                 <a:cs typeface="Calibri" pitchFamily="34" charset="-120"/>
               </a:rPr>
-              <a:t>eology GmbH  ·  KI-Sichtbarkeit Sparkasse Düren  ·  Peec AI Monitoring 23.07.–03.08.2026</a:t>
+              <a:t>eology GmbH  ·  KI-Sichtbarkeit Sparkasse Düren  ·  Peec AI Monitoring 04.07.–03.08.2026 (30 Tage, n = 61 Chats)</a:t>
             </a:r>
             <a:endParaRPr lang="en-US" sz="900" dirty="0"/>
           </a:p>

</xml_diff>

<commit_message>
sparkasse-dueren: Volksbank-Hotspot auf Kontoeroeffnung hervorheben
- Slide 2 Signal 01 auf "Kontoeroeffnung ist Ihr Hotspot" zugespitzt
- Slide 4: Konto-Zeile mit Warn-Rahmen + HOTSPOT-Chip visuell markiert
- Slide 4 Bottom-Bar ersetzt: generischer CHANCE-Text raus,
  grosser COMPETITIVE-HOTSPOT-Alarm in Warn-Farbe rein

Co-Authored-By: Claude Opus 4.7 <noreply@anthropic.com>
Claude-Session: https://claude.ai/code/session_019JdfnJd2Mr6vK4FK3ePtt7
</commit_message>
<xml_diff>
--- a/kunden/sparkasse-dueren/decks/sparkasse_dueren_pitch.pptx
+++ b/kunden/sparkasse-dueren/decks/sparkasse_dueren_pitch.pptx
@@ -2972,7 +2972,7 @@
                 <a:ea typeface="Calibri" pitchFamily="34" charset="-122"/>
                 <a:cs typeface="Calibri" pitchFamily="34" charset="-120"/>
               </a:rPr>
-              <a:t>Volksbank Euskirchen holt strategisch auf.</a:t>
+              <a:t>Kontoeröffnung ist Ihr Hotspot – und Volksbank drängt rein.</a:t>
             </a:r>
             <a:endParaRPr lang="en-US" sz="1500" dirty="0"/>
           </a:p>
@@ -3014,7 +3014,7 @@
                 <a:ea typeface="Calibri" pitchFamily="34" charset="-122"/>
                 <a:cs typeface="Calibri" pitchFamily="34" charset="-120"/>
               </a:rPr>
-              <a:t>Bei „Konto im Kreis Düren eröffnen“ bereits 66,7 % Sichtbarkeit; in Google AI Overview über alle Prompts hinweg 21,1 % (Sie: 63,2 %). Belegt: aktive Konkurrenz um Ihre kaufentscheidenden Kundenfragen.</a:t>
+              <a:t>Bei der umsatzrelevantesten Kundenfrage „Konto im Kreis Düren eröffnen“ erscheint Volksbank Euskirchen in 2 von 3 KI-Antworten neben Ihnen (66,7 % Visibility). Bei allen anderen 5 Prompts liegt sie unter 25 % – der Wettbewerber hat sein Fokus-Thema klar gewählt.</a:t>
             </a:r>
             <a:endParaRPr lang="en-US" sz="1050" dirty="0"/>
           </a:p>
@@ -5210,11 +5210,11 @@
             <a:avLst/>
           </a:prstGeom>
           <a:solidFill>
-            <a:srgbClr val="FFFFFF"/>
+            <a:srgbClr val="FFF1EC"/>
           </a:solidFill>
-          <a:ln w="6350">
+          <a:ln w="19050">
             <a:solidFill>
-              <a:srgbClr val="E5F4F8"/>
+              <a:srgbClr val="FF6B4A"/>
             </a:solidFill>
             <a:prstDash val="solid"/>
           </a:ln>
@@ -5223,6 +5223,70 @@
       <p:sp>
         <p:nvSpPr>
           <p:cNvPr id="11" name="Shape 9"/>
+          <p:cNvSpPr/>
+          <p:nvPr/>
+        </p:nvSpPr>
+        <p:spPr>
+          <a:xfrm>
+            <a:off x="4846320" y="2697480"/>
+            <a:ext cx="1417320" cy="219456"/>
+          </a:xfrm>
+          <a:prstGeom prst="rect">
+            <a:avLst/>
+          </a:prstGeom>
+          <a:solidFill>
+            <a:srgbClr val="FF6B4A"/>
+          </a:solidFill>
+          <a:ln w="12700">
+            <a:solidFill>
+              <a:srgbClr val="FF6B4A"/>
+            </a:solidFill>
+            <a:prstDash val="solid"/>
+          </a:ln>
+        </p:spPr>
+      </p:sp>
+      <p:sp>
+        <p:nvSpPr>
+          <p:cNvPr id="12" name="Text 10"/>
+          <p:cNvSpPr/>
+          <p:nvPr/>
+        </p:nvSpPr>
+        <p:spPr>
+          <a:xfrm>
+            <a:off x="4846320" y="2697480"/>
+            <a:ext cx="1417320" cy="219456"/>
+          </a:xfrm>
+          <a:prstGeom prst="rect">
+            <a:avLst/>
+          </a:prstGeom>
+          <a:noFill/>
+          <a:ln/>
+        </p:spPr>
+        <p:txBody>
+          <a:bodyPr wrap="square" lIns="0" tIns="0" rIns="0" bIns="0" rtlCol="0" anchor="ctr"/>
+          <a:lstStyle/>
+          <a:p>
+            <a:pPr algn="ctr" indent="0" marL="0">
+              <a:buNone/>
+            </a:pPr>
+            <a:r>
+              <a:rPr lang="en-US" sz="850" b="1" spc="200" kern="0" dirty="0">
+                <a:solidFill>
+                  <a:srgbClr val="FFFFFF"/>
+                </a:solidFill>
+                <a:latin typeface="Calibri" pitchFamily="34" charset="0"/>
+                <a:ea typeface="Calibri" pitchFamily="34" charset="-122"/>
+                <a:cs typeface="Calibri" pitchFamily="34" charset="-120"/>
+              </a:rPr>
+              <a:t>⚠ HOTSPOT</a:t>
+            </a:r>
+            <a:endParaRPr lang="en-US" sz="850" dirty="0"/>
+          </a:p>
+        </p:txBody>
+      </p:sp>
+      <p:sp>
+        <p:nvSpPr>
+          <p:cNvPr id="13" name="Shape 11"/>
           <p:cNvSpPr/>
           <p:nvPr/>
         </p:nvSpPr>
@@ -5247,7 +5311,7 @@
       </p:sp>
       <p:sp>
         <p:nvSpPr>
-          <p:cNvPr id="12" name="Text 10"/>
+          <p:cNvPr id="14" name="Text 12"/>
           <p:cNvSpPr/>
           <p:nvPr/>
         </p:nvSpPr>
@@ -5286,7 +5350,7 @@
       </p:sp>
       <p:sp>
         <p:nvSpPr>
-          <p:cNvPr id="13" name="Text 11"/>
+          <p:cNvPr id="15" name="Text 13"/>
           <p:cNvSpPr/>
           <p:nvPr/>
         </p:nvSpPr>
@@ -5325,7 +5389,7 @@
       </p:sp>
       <p:sp>
         <p:nvSpPr>
-          <p:cNvPr id="14" name="Text 12"/>
+          <p:cNvPr id="16" name="Text 14"/>
           <p:cNvSpPr/>
           <p:nvPr/>
         </p:nvSpPr>
@@ -5348,7 +5412,7 @@
               <a:buNone/>
             </a:pPr>
             <a:r>
-              <a:rPr lang="en-US" sz="850" i="1" dirty="0">
+              <a:rPr lang="en-US" sz="950" b="1" i="1" dirty="0">
                 <a:solidFill>
                   <a:srgbClr val="FF6B4A"/>
                 </a:solidFill>
@@ -5356,15 +5420,15 @@
                 <a:ea typeface="Calibri" pitchFamily="34" charset="-122"/>
                 <a:cs typeface="Calibri" pitchFamily="34" charset="-120"/>
               </a:rPr>
-              <a:t>⚠ Volksbank auch 66,7 %</a:t>
-            </a:r>
-            <a:endParaRPr lang="en-US" sz="850" dirty="0"/>
-          </a:p>
-        </p:txBody>
-      </p:sp>
-      <p:sp>
-        <p:nvSpPr>
-          <p:cNvPr id="15" name="Shape 13"/>
+              <a:t>Volksbank 66,7 %</a:t>
+            </a:r>
+            <a:endParaRPr lang="en-US" sz="950" dirty="0"/>
+          </a:p>
+        </p:txBody>
+      </p:sp>
+      <p:sp>
+        <p:nvSpPr>
+          <p:cNvPr id="17" name="Shape 15"/>
           <p:cNvSpPr/>
           <p:nvPr/>
         </p:nvSpPr>
@@ -5389,7 +5453,7 @@
       </p:sp>
       <p:sp>
         <p:nvSpPr>
-          <p:cNvPr id="16" name="Shape 14"/>
+          <p:cNvPr id="18" name="Shape 16"/>
           <p:cNvSpPr/>
           <p:nvPr/>
         </p:nvSpPr>
@@ -5414,7 +5478,7 @@
       </p:sp>
       <p:sp>
         <p:nvSpPr>
-          <p:cNvPr id="17" name="Text 15"/>
+          <p:cNvPr id="19" name="Text 17"/>
           <p:cNvSpPr/>
           <p:nvPr/>
         </p:nvSpPr>
@@ -5453,7 +5517,7 @@
       </p:sp>
       <p:sp>
         <p:nvSpPr>
-          <p:cNvPr id="18" name="Text 16"/>
+          <p:cNvPr id="20" name="Text 18"/>
           <p:cNvSpPr/>
           <p:nvPr/>
         </p:nvSpPr>
@@ -5492,7 +5556,7 @@
       </p:sp>
       <p:sp>
         <p:nvSpPr>
-          <p:cNvPr id="19" name="Shape 17"/>
+          <p:cNvPr id="21" name="Shape 19"/>
           <p:cNvSpPr/>
           <p:nvPr/>
         </p:nvSpPr>
@@ -5517,7 +5581,7 @@
       </p:sp>
       <p:sp>
         <p:nvSpPr>
-          <p:cNvPr id="20" name="Shape 18"/>
+          <p:cNvPr id="22" name="Shape 20"/>
           <p:cNvSpPr/>
           <p:nvPr/>
         </p:nvSpPr>
@@ -5542,7 +5606,7 @@
       </p:sp>
       <p:sp>
         <p:nvSpPr>
-          <p:cNvPr id="21" name="Text 19"/>
+          <p:cNvPr id="23" name="Text 21"/>
           <p:cNvSpPr/>
           <p:nvPr/>
         </p:nvSpPr>
@@ -5581,7 +5645,7 @@
       </p:sp>
       <p:sp>
         <p:nvSpPr>
-          <p:cNvPr id="22" name="Text 20"/>
+          <p:cNvPr id="24" name="Text 22"/>
           <p:cNvSpPr/>
           <p:nvPr/>
         </p:nvSpPr>
@@ -5620,7 +5684,7 @@
       </p:sp>
       <p:sp>
         <p:nvSpPr>
-          <p:cNvPr id="23" name="Shape 21"/>
+          <p:cNvPr id="25" name="Shape 23"/>
           <p:cNvSpPr/>
           <p:nvPr/>
         </p:nvSpPr>
@@ -5645,7 +5709,7 @@
       </p:sp>
       <p:sp>
         <p:nvSpPr>
-          <p:cNvPr id="24" name="Shape 22"/>
+          <p:cNvPr id="26" name="Shape 24"/>
           <p:cNvSpPr/>
           <p:nvPr/>
         </p:nvSpPr>
@@ -5670,7 +5734,7 @@
       </p:sp>
       <p:sp>
         <p:nvSpPr>
-          <p:cNvPr id="25" name="Text 23"/>
+          <p:cNvPr id="27" name="Text 25"/>
           <p:cNvSpPr/>
           <p:nvPr/>
         </p:nvSpPr>
@@ -5709,7 +5773,7 @@
       </p:sp>
       <p:sp>
         <p:nvSpPr>
-          <p:cNvPr id="26" name="Text 24"/>
+          <p:cNvPr id="28" name="Text 26"/>
           <p:cNvSpPr/>
           <p:nvPr/>
         </p:nvSpPr>
@@ -5748,7 +5812,7 @@
       </p:sp>
       <p:sp>
         <p:nvSpPr>
-          <p:cNvPr id="27" name="Shape 25"/>
+          <p:cNvPr id="29" name="Shape 27"/>
           <p:cNvSpPr/>
           <p:nvPr/>
         </p:nvSpPr>
@@ -5773,7 +5837,7 @@
       </p:sp>
       <p:sp>
         <p:nvSpPr>
-          <p:cNvPr id="28" name="Shape 26"/>
+          <p:cNvPr id="30" name="Shape 28"/>
           <p:cNvSpPr/>
           <p:nvPr/>
         </p:nvSpPr>
@@ -5798,7 +5862,7 @@
       </p:sp>
       <p:sp>
         <p:nvSpPr>
-          <p:cNvPr id="29" name="Text 27"/>
+          <p:cNvPr id="31" name="Text 29"/>
           <p:cNvSpPr/>
           <p:nvPr/>
         </p:nvSpPr>
@@ -5837,7 +5901,7 @@
       </p:sp>
       <p:sp>
         <p:nvSpPr>
-          <p:cNvPr id="30" name="Text 28"/>
+          <p:cNvPr id="32" name="Text 30"/>
           <p:cNvSpPr/>
           <p:nvPr/>
         </p:nvSpPr>
@@ -5876,7 +5940,7 @@
       </p:sp>
       <p:sp>
         <p:nvSpPr>
-          <p:cNvPr id="31" name="Text 29"/>
+          <p:cNvPr id="33" name="Text 31"/>
           <p:cNvSpPr/>
           <p:nvPr/>
         </p:nvSpPr>
@@ -5915,7 +5979,7 @@
       </p:sp>
       <p:sp>
         <p:nvSpPr>
-          <p:cNvPr id="32" name="Text 30"/>
+          <p:cNvPr id="34" name="Text 32"/>
           <p:cNvSpPr/>
           <p:nvPr/>
         </p:nvSpPr>
@@ -5954,7 +6018,7 @@
       </p:sp>
       <p:graphicFrame>
         <p:nvGraphicFramePr>
-          <p:cNvPr id="33" name="Chart 0" descr=""/>
+          <p:cNvPr id="35" name="Chart 0" descr=""/>
           <p:cNvGraphicFramePr/>
           <p:nvPr/>
         </p:nvGraphicFramePr>
@@ -5970,26 +6034,26 @@
       </p:graphicFrame>
       <p:sp>
         <p:nvSpPr>
-          <p:cNvPr id="34" name="Shape 31"/>
-          <p:cNvSpPr/>
-          <p:nvPr/>
-        </p:nvSpPr>
-        <p:spPr>
-          <a:xfrm>
-            <a:off x="457200" y="5943600"/>
-            <a:ext cx="11247120" cy="457200"/>
+          <p:cNvPr id="36" name="Shape 33"/>
+          <p:cNvSpPr/>
+          <p:nvPr/>
+        </p:nvSpPr>
+        <p:spPr>
+          <a:xfrm>
+            <a:off x="457200" y="5806440"/>
+            <a:ext cx="11247120" cy="594360"/>
           </a:xfrm>
           <a:prstGeom prst="roundRect">
             <a:avLst>
-              <a:gd name="adj" fmla="val 10000"/>
+              <a:gd name="adj" fmla="val 9231"/>
             </a:avLst>
           </a:prstGeom>
           <a:solidFill>
-            <a:srgbClr val="0A1117"/>
+            <a:srgbClr val="FF6B4A"/>
           </a:solidFill>
           <a:ln w="12700">
             <a:solidFill>
-              <a:srgbClr val="0A1117"/>
+              <a:srgbClr val="FF6B4A"/>
             </a:solidFill>
             <a:prstDash val="solid"/>
           </a:ln>
@@ -5997,38 +6061,77 @@
       </p:sp>
       <p:sp>
         <p:nvSpPr>
-          <p:cNvPr id="35" name="Text 32"/>
-          <p:cNvSpPr/>
-          <p:nvPr/>
-        </p:nvSpPr>
-        <p:spPr>
-          <a:xfrm>
-            <a:off x="685800" y="5943600"/>
-            <a:ext cx="10881360" cy="457200"/>
-          </a:xfrm>
-          <a:prstGeom prst="rect">
-            <a:avLst/>
-          </a:prstGeom>
-          <a:noFill/>
-          <a:ln/>
-        </p:spPr>
-        <p:txBody>
-          <a:bodyPr wrap="square" lIns="0" tIns="0" rIns="0" bIns="0" rtlCol="0" anchor="ctr"/>
-          <a:lstStyle/>
-          <a:p>
-            <a:pPr indent="0" marL="0">
-              <a:buNone/>
-            </a:pPr>
-            <a:r>
-              <a:rPr lang="en-US" sz="1000" b="1" spc="300" kern="0" dirty="0">
-                <a:solidFill>
-                  <a:srgbClr val="54C7E8"/>
-                </a:solidFill>
-                <a:latin typeface="Calibri" pitchFamily="34" charset="0"/>
-                <a:ea typeface="Calibri" pitchFamily="34" charset="-122"/>
-                <a:cs typeface="Calibri" pitchFamily="34" charset="-120"/>
-              </a:rPr>
-              <a:t>CHANCE  </a:t>
+          <p:cNvPr id="37" name="Text 34"/>
+          <p:cNvSpPr/>
+          <p:nvPr/>
+        </p:nvSpPr>
+        <p:spPr>
+          <a:xfrm>
+            <a:off x="685800" y="5852160"/>
+            <a:ext cx="10881360" cy="256032"/>
+          </a:xfrm>
+          <a:prstGeom prst="rect">
+            <a:avLst/>
+          </a:prstGeom>
+          <a:noFill/>
+          <a:ln/>
+        </p:spPr>
+        <p:txBody>
+          <a:bodyPr wrap="square" lIns="0" tIns="0" rIns="0" bIns="0" rtlCol="0" anchor="ctr"/>
+          <a:lstStyle/>
+          <a:p>
+            <a:pPr indent="0" marL="0">
+              <a:buNone/>
+            </a:pPr>
+            <a:r>
+              <a:rPr lang="en-US" sz="1100" b="1" spc="300" kern="0" dirty="0">
+                <a:solidFill>
+                  <a:srgbClr val="FFFFFF"/>
+                </a:solidFill>
+                <a:latin typeface="Calibri" pitchFamily="34" charset="0"/>
+                <a:ea typeface="Calibri" pitchFamily="34" charset="-122"/>
+                <a:cs typeface="Calibri" pitchFamily="34" charset="-120"/>
+              </a:rPr>
+              <a:t>⚠ COMPETITIVE HOTSPOT · KONTOERÖFFNUNG</a:t>
+            </a:r>
+            <a:endParaRPr lang="en-US" sz="1100" dirty="0"/>
+          </a:p>
+        </p:txBody>
+      </p:sp>
+      <p:sp>
+        <p:nvSpPr>
+          <p:cNvPr id="38" name="Text 35"/>
+          <p:cNvSpPr/>
+          <p:nvPr/>
+        </p:nvSpPr>
+        <p:spPr>
+          <a:xfrm>
+            <a:off x="685800" y="6080760"/>
+            <a:ext cx="10881360" cy="320040"/>
+          </a:xfrm>
+          <a:prstGeom prst="rect">
+            <a:avLst/>
+          </a:prstGeom>
+          <a:noFill/>
+          <a:ln/>
+        </p:spPr>
+        <p:txBody>
+          <a:bodyPr wrap="square" lIns="0" tIns="0" rIns="0" bIns="0" rtlCol="0" anchor="ctr"/>
+          <a:lstStyle/>
+          <a:p>
+            <a:pPr indent="0" marL="0">
+              <a:buNone/>
+            </a:pPr>
+            <a:r>
+              <a:rPr lang="en-US" sz="1100" b="1" dirty="0">
+                <a:solidFill>
+                  <a:srgbClr val="FFFFFF"/>
+                </a:solidFill>
+                <a:latin typeface="Calibri" pitchFamily="34" charset="0"/>
+                <a:ea typeface="Calibri" pitchFamily="34" charset="-122"/>
+                <a:cs typeface="Calibri" pitchFamily="34" charset="-120"/>
+              </a:rPr>
+              <a:t>In 2 von 3 KI-Antworten zur Kontoeröffnung erscheint die Volksbank Euskirchen direkt neben Ihnen. </a:t>
             </a:r>
             <a:pPr indent="0" marL="0">
               <a:buNone/>
@@ -6042,15 +6145,15 @@
                 <a:ea typeface="Calibri" pitchFamily="34" charset="-122"/>
                 <a:cs typeface="Calibri" pitchFamily="34" charset="-120"/>
               </a:rPr>
-              <a:t>Institutionelle Quellen (kreis-dueren.de, Verbraucherzentrale, KfW, Deutsche Rentenversicherung) dominieren – dort platzieren wir Sie durch digitale PR und Content-Kooperationen.</a:t>
-            </a:r>
-            <a:endParaRPr lang="en-US" sz="1000" dirty="0"/>
-          </a:p>
-        </p:txBody>
-      </p:sp>
-      <p:sp>
-        <p:nvSpPr>
-          <p:cNvPr id="36" name="Text 33"/>
+              <a:t>Kein anderer Prompt zeigt so hohe Wettbewerbs-Konzentration – das ist der Kanal, den Sie exklusiv zurückerobern müssen.</a:t>
+            </a:r>
+            <a:endParaRPr lang="en-US" sz="1100" dirty="0"/>
+          </a:p>
+        </p:txBody>
+      </p:sp>
+      <p:sp>
+        <p:nvSpPr>
+          <p:cNvPr id="39" name="Text 36"/>
           <p:cNvSpPr/>
           <p:nvPr/>
         </p:nvSpPr>
@@ -6089,7 +6192,7 @@
       </p:sp>
       <p:sp>
         <p:nvSpPr>
-          <p:cNvPr id="37" name="Text 34"/>
+          <p:cNvPr id="40" name="Text 37"/>
           <p:cNvSpPr/>
           <p:nvPr/>
         </p:nvSpPr>

</xml_diff>

<commit_message>
sparkasse-dueren: Prompt-Analyse als 5. Insight auf Folie 2
Ergaenzt kompakte Meta-Insight-Bar unter den 4 Signal-Cards:
- Rentenberatung ist DRV-Thema (semantisch nicht Sparkasse-Feld)
- Erbschaft-Prompt ist Info-Frage ohne Anbieter-Empfehlung
- Empfehlung: Prompts neu formulieren + Landingpages schaffen

Co-Authored-By: Claude Opus 4.7 <noreply@anthropic.com>
Claude-Session: https://claude.ai/code/session_019JdfnJd2Mr6vK4FK3ePtt7
</commit_message>
<xml_diff>
--- a/kunden/sparkasse-dueren/decks/sparkasse_dueren_pitch.pptx
+++ b/kunden/sparkasse-dueren/decks/sparkasse_dueren_pitch.pptx
@@ -2878,12 +2878,12 @@
         </p:nvSpPr>
         <p:spPr>
           <a:xfrm>
-            <a:off x="457200" y="2194560"/>
-            <a:ext cx="5486400" cy="2057400"/>
+            <a:off x="457200" y="2148840"/>
+            <a:ext cx="5486400" cy="1737360"/>
           </a:xfrm>
           <a:prstGeom prst="roundRect">
             <a:avLst>
-              <a:gd name="adj" fmla="val 2667"/>
+              <a:gd name="adj" fmla="val 3158"/>
             </a:avLst>
           </a:prstGeom>
           <a:solidFill>
@@ -2905,7 +2905,7 @@
         </p:nvSpPr>
         <p:spPr>
           <a:xfrm>
-            <a:off x="731520" y="2423160"/>
+            <a:off x="731520" y="2377440"/>
             <a:ext cx="1097280" cy="822960"/>
           </a:xfrm>
           <a:prstGeom prst="rect">
@@ -2944,7 +2944,7 @@
         </p:nvSpPr>
         <p:spPr>
           <a:xfrm>
-            <a:off x="1874520" y="2423160"/>
+            <a:off x="1874520" y="2377440"/>
             <a:ext cx="3840480" cy="822960"/>
           </a:xfrm>
           <a:prstGeom prst="rect">
@@ -2986,8 +2986,8 @@
         </p:nvSpPr>
         <p:spPr>
           <a:xfrm>
-            <a:off x="1874520" y="3200400"/>
-            <a:ext cx="3840480" cy="1005840"/>
+            <a:off x="1874520" y="3063240"/>
+            <a:ext cx="3840480" cy="777240"/>
           </a:xfrm>
           <a:prstGeom prst="rect">
             <a:avLst/>
@@ -3006,7 +3006,7 @@
               <a:buNone/>
             </a:pPr>
             <a:r>
-              <a:rPr lang="en-US" sz="1050" dirty="0">
+              <a:rPr lang="en-US" sz="1000" dirty="0">
                 <a:solidFill>
                   <a:srgbClr val="2C3338"/>
                 </a:solidFill>
@@ -3016,7 +3016,7 @@
               </a:rPr>
               <a:t>Bei der umsatzrelevantesten Kundenfrage „Konto im Kreis Düren eröffnen“ erscheint Volksbank Euskirchen in 2 von 3 KI-Antworten neben Ihnen (66,7 % Visibility). Bei allen anderen 5 Prompts liegt sie unter 25 % – der Wettbewerber hat sein Fokus-Thema klar gewählt.</a:t>
             </a:r>
-            <a:endParaRPr lang="en-US" sz="1050" dirty="0"/>
+            <a:endParaRPr lang="en-US" sz="1000" dirty="0"/>
           </a:p>
         </p:txBody>
       </p:sp>
@@ -3028,12 +3028,12 @@
         </p:nvSpPr>
         <p:spPr>
           <a:xfrm>
-            <a:off x="6126480" y="2194560"/>
-            <a:ext cx="5486400" cy="2057400"/>
+            <a:off x="6126480" y="2148840"/>
+            <a:ext cx="5486400" cy="1737360"/>
           </a:xfrm>
           <a:prstGeom prst="roundRect">
             <a:avLst>
-              <a:gd name="adj" fmla="val 2667"/>
+              <a:gd name="adj" fmla="val 3158"/>
             </a:avLst>
           </a:prstGeom>
           <a:solidFill>
@@ -3055,7 +3055,7 @@
         </p:nvSpPr>
         <p:spPr>
           <a:xfrm>
-            <a:off x="6400800" y="2423160"/>
+            <a:off x="6400800" y="2377440"/>
             <a:ext cx="1097280" cy="822960"/>
           </a:xfrm>
           <a:prstGeom prst="rect">
@@ -3094,7 +3094,7 @@
         </p:nvSpPr>
         <p:spPr>
           <a:xfrm>
-            <a:off x="7543800" y="2423160"/>
+            <a:off x="7543800" y="2377440"/>
             <a:ext cx="3840480" cy="822960"/>
           </a:xfrm>
           <a:prstGeom prst="rect">
@@ -3136,8 +3136,8 @@
         </p:nvSpPr>
         <p:spPr>
           <a:xfrm>
-            <a:off x="7543800" y="3200400"/>
-            <a:ext cx="3840480" cy="1005840"/>
+            <a:off x="7543800" y="3063240"/>
+            <a:ext cx="3840480" cy="777240"/>
           </a:xfrm>
           <a:prstGeom prst="rect">
             <a:avLst/>
@@ -3156,7 +3156,7 @@
               <a:buNone/>
             </a:pPr>
             <a:r>
-              <a:rPr lang="en-US" sz="1050" dirty="0">
+              <a:rPr lang="en-US" sz="1000" dirty="0">
                 <a:solidFill>
                   <a:srgbClr val="2C3338"/>
                 </a:solidFill>
@@ -3166,7 +3166,7 @@
               </a:rPr>
               <a:t>Sentiment (0–100) misst, wie positiv KI-Systeme über eine Marke sprechen; Normalbereich 65–85. Höhere Wettbewerbswerte (Commerzbank 73, Deutsche Bank 56) basieren auf nur 1 auswertbaren Nennung – statistisch nicht belastbar. Bei Ihnen sind 45 Bewertungen repräsentativ und optimierbar.</a:t>
             </a:r>
-            <a:endParaRPr lang="en-US" sz="1050" dirty="0"/>
+            <a:endParaRPr lang="en-US" sz="1000" dirty="0"/>
           </a:p>
         </p:txBody>
       </p:sp>
@@ -3178,12 +3178,12 @@
         </p:nvSpPr>
         <p:spPr>
           <a:xfrm>
-            <a:off x="457200" y="4434840"/>
-            <a:ext cx="5486400" cy="2057400"/>
+            <a:off x="457200" y="4069080"/>
+            <a:ext cx="5486400" cy="1737360"/>
           </a:xfrm>
           <a:prstGeom prst="roundRect">
             <a:avLst>
-              <a:gd name="adj" fmla="val 2667"/>
+              <a:gd name="adj" fmla="val 3158"/>
             </a:avLst>
           </a:prstGeom>
           <a:solidFill>
@@ -3205,7 +3205,7 @@
         </p:nvSpPr>
         <p:spPr>
           <a:xfrm>
-            <a:off x="731520" y="4663440"/>
+            <a:off x="731520" y="4297680"/>
             <a:ext cx="1097280" cy="822960"/>
           </a:xfrm>
           <a:prstGeom prst="rect">
@@ -3244,7 +3244,7 @@
         </p:nvSpPr>
         <p:spPr>
           <a:xfrm>
-            <a:off x="1874520" y="4663440"/>
+            <a:off x="1874520" y="4297680"/>
             <a:ext cx="3840480" cy="822960"/>
           </a:xfrm>
           <a:prstGeom prst="rect">
@@ -3286,8 +3286,8 @@
         </p:nvSpPr>
         <p:spPr>
           <a:xfrm>
-            <a:off x="1874520" y="5440680"/>
-            <a:ext cx="3840480" cy="1005840"/>
+            <a:off x="1874520" y="4983480"/>
+            <a:ext cx="3840480" cy="777240"/>
           </a:xfrm>
           <a:prstGeom prst="rect">
             <a:avLst/>
@@ -3306,7 +3306,7 @@
               <a:buNone/>
             </a:pPr>
             <a:r>
-              <a:rPr lang="en-US" sz="1050" dirty="0">
+              <a:rPr lang="en-US" sz="1000" dirty="0">
                 <a:solidFill>
                   <a:srgbClr val="2C3338"/>
                 </a:solidFill>
@@ -3316,7 +3316,7 @@
               </a:rPr>
               <a:t>42,9 % Sichtbarkeit bei Ihnen – alle drei Wettbewerber bei 0 %. Damit haben Sie hier das größte Delta zum Maximum (57 PP nach oben, Gemini nur 29, AIO nur 37) und den einzigen KI-Kanal, in dem Sie exklusiv sind.</a:t>
             </a:r>
-            <a:endParaRPr lang="en-US" sz="1050" dirty="0"/>
+            <a:endParaRPr lang="en-US" sz="1000" dirty="0"/>
           </a:p>
         </p:txBody>
       </p:sp>
@@ -3328,12 +3328,12 @@
         </p:nvSpPr>
         <p:spPr>
           <a:xfrm>
-            <a:off x="6126480" y="4434840"/>
-            <a:ext cx="5486400" cy="2057400"/>
+            <a:off x="6126480" y="4069080"/>
+            <a:ext cx="5486400" cy="1737360"/>
           </a:xfrm>
           <a:prstGeom prst="roundRect">
             <a:avLst>
-              <a:gd name="adj" fmla="val 2667"/>
+              <a:gd name="adj" fmla="val 3158"/>
             </a:avLst>
           </a:prstGeom>
           <a:solidFill>
@@ -3355,7 +3355,7 @@
         </p:nvSpPr>
         <p:spPr>
           <a:xfrm>
-            <a:off x="6400800" y="4663440"/>
+            <a:off x="6400800" y="4297680"/>
             <a:ext cx="1097280" cy="822960"/>
           </a:xfrm>
           <a:prstGeom prst="rect">
@@ -3394,7 +3394,7 @@
         </p:nvSpPr>
         <p:spPr>
           <a:xfrm>
-            <a:off x="7543800" y="4663440"/>
+            <a:off x="7543800" y="4297680"/>
             <a:ext cx="3840480" cy="822960"/>
           </a:xfrm>
           <a:prstGeom prst="rect">
@@ -3436,8 +3436,8 @@
         </p:nvSpPr>
         <p:spPr>
           <a:xfrm>
-            <a:off x="7543800" y="5440680"/>
-            <a:ext cx="3840480" cy="1005840"/>
+            <a:off x="7543800" y="4983480"/>
+            <a:ext cx="3840480" cy="777240"/>
           </a:xfrm>
           <a:prstGeom prst="rect">
             <a:avLst/>
@@ -3456,7 +3456,7 @@
               <a:buNone/>
             </a:pPr>
             <a:r>
-              <a:rPr lang="en-US" sz="1050" dirty="0">
+              <a:rPr lang="en-US" sz="1000" dirty="0">
                 <a:solidFill>
                   <a:srgbClr val="2C3338"/>
                 </a:solidFill>
@@ -3466,13 +3466,121 @@
               </a:rPr>
               <a:t>kreis-dueren.de (28 Zitierungen), dueren.de (14), Verbraucherzentrale (15), Deutsche Rentenversicherung (12) und KfW (9) stellen die Quellen der KI. Gezielte PR- &amp; Kooperations-Arbeit macht Sie dort zitierfähig.</a:t>
             </a:r>
-            <a:endParaRPr lang="en-US" sz="1050" dirty="0"/>
-          </a:p>
-        </p:txBody>
-      </p:sp>
-      <p:sp>
-        <p:nvSpPr>
-          <p:cNvPr id="23" name="Text 21"/>
+            <a:endParaRPr lang="en-US" sz="1000" dirty="0"/>
+          </a:p>
+        </p:txBody>
+      </p:sp>
+      <p:sp>
+        <p:nvSpPr>
+          <p:cNvPr id="23" name="Shape 21"/>
+          <p:cNvSpPr/>
+          <p:nvPr/>
+        </p:nvSpPr>
+        <p:spPr>
+          <a:xfrm>
+            <a:off x="457200" y="5989320"/>
+            <a:ext cx="11247120" cy="457200"/>
+          </a:xfrm>
+          <a:prstGeom prst="roundRect">
+            <a:avLst>
+              <a:gd name="adj" fmla="val 10000"/>
+            </a:avLst>
+          </a:prstGeom>
+          <a:solidFill>
+            <a:srgbClr val="0A1117"/>
+          </a:solidFill>
+          <a:ln w="12700">
+            <a:solidFill>
+              <a:srgbClr val="0A1117"/>
+            </a:solidFill>
+            <a:prstDash val="solid"/>
+          </a:ln>
+        </p:spPr>
+      </p:sp>
+      <p:sp>
+        <p:nvSpPr>
+          <p:cNvPr id="24" name="Text 22"/>
+          <p:cNvSpPr/>
+          <p:nvPr/>
+        </p:nvSpPr>
+        <p:spPr>
+          <a:xfrm>
+            <a:off x="685800" y="5989320"/>
+            <a:ext cx="10881360" cy="457200"/>
+          </a:xfrm>
+          <a:prstGeom prst="rect">
+            <a:avLst/>
+          </a:prstGeom>
+          <a:noFill/>
+          <a:ln/>
+        </p:spPr>
+        <p:txBody>
+          <a:bodyPr wrap="square" lIns="0" tIns="0" rIns="0" bIns="0" rtlCol="0" anchor="ctr"/>
+          <a:lstStyle/>
+          <a:p>
+            <a:pPr indent="0" marL="0">
+              <a:buNone/>
+            </a:pPr>
+            <a:r>
+              <a:rPr lang="en-US" sz="1000" b="1" spc="300" kern="0" dirty="0">
+                <a:solidFill>
+                  <a:srgbClr val="54C7E8"/>
+                </a:solidFill>
+                <a:latin typeface="Calibri" pitchFamily="34" charset="0"/>
+                <a:ea typeface="Calibri" pitchFamily="34" charset="-122"/>
+                <a:cs typeface="Calibri" pitchFamily="34" charset="-120"/>
+              </a:rPr>
+              <a:t>PROMPT-ANALYSE  ·  </a:t>
+            </a:r>
+            <a:pPr indent="0" marL="0">
+              <a:buNone/>
+            </a:pPr>
+            <a:r>
+              <a:rPr lang="en-US" sz="1100" dirty="0">
+                <a:solidFill>
+                  <a:srgbClr val="FFFFFF"/>
+                </a:solidFill>
+                <a:latin typeface="Calibri" pitchFamily="34" charset="0"/>
+                <a:ea typeface="Calibri" pitchFamily="34" charset="-122"/>
+                <a:cs typeface="Calibri" pitchFamily="34" charset="-120"/>
+              </a:rPr>
+              <a:t>Die 0 %-Prompts (Rentenberatung, Erbschaft) sind </a:t>
+            </a:r>
+            <a:pPr indent="0" marL="0">
+              <a:buNone/>
+            </a:pPr>
+            <a:r>
+              <a:rPr lang="en-US" sz="1100" b="1" dirty="0">
+                <a:solidFill>
+                  <a:srgbClr val="54C7E8"/>
+                </a:solidFill>
+                <a:latin typeface="Calibri" pitchFamily="34" charset="0"/>
+                <a:ea typeface="Calibri" pitchFamily="34" charset="-122"/>
+                <a:cs typeface="Calibri" pitchFamily="34" charset="-120"/>
+              </a:rPr>
+              <a:t>semantisch anders belegt</a:t>
+            </a:r>
+            <a:pPr indent="0" marL="0">
+              <a:buNone/>
+            </a:pPr>
+            <a:r>
+              <a:rPr lang="en-US" sz="1100" dirty="0">
+                <a:solidFill>
+                  <a:srgbClr val="FFFFFF"/>
+                </a:solidFill>
+                <a:latin typeface="Calibri" pitchFamily="34" charset="0"/>
+                <a:ea typeface="Calibri" pitchFamily="34" charset="-122"/>
+                <a:cs typeface="Calibri" pitchFamily="34" charset="-120"/>
+              </a:rPr>
+              <a:t> – „Rentenberatung“ meint DRV/Behörde, „Was mache ich mit meinem Erbe“ ist Info-Frage. Wir formulieren die Prompts neu und schaffen die passenden Landingpages.</a:t>
+            </a:r>
+            <a:endParaRPr lang="en-US" sz="1000" dirty="0"/>
+          </a:p>
+        </p:txBody>
+      </p:sp>
+      <p:sp>
+        <p:nvSpPr>
+          <p:cNvPr id="25" name="Text 23"/>
           <p:cNvSpPr/>
           <p:nvPr/>
         </p:nvSpPr>
@@ -3511,7 +3619,7 @@
       </p:sp>
       <p:sp>
         <p:nvSpPr>
-          <p:cNvPr id="24" name="Text 22"/>
+          <p:cNvPr id="26" name="Text 24"/>
           <p:cNvSpPr/>
           <p:nvPr/>
         </p:nvSpPr>

</xml_diff>

<commit_message>
sparkasse-dueren: Kontaktfolie Mario Strack (CGO) als Slide 6
Co-Authored-By: Claude Opus 4.7 <noreply@anthropic.com>
Claude-Session: https://claude.ai/code/session_019JdfnJd2Mr6vK4FK3ePtt7
</commit_message>
<xml_diff>
--- a/kunden/sparkasse-dueren/decks/sparkasse_dueren_pitch.pptx
+++ b/kunden/sparkasse-dueren/decks/sparkasse_dueren_pitch.pptx
@@ -10,9 +10,10 @@
     <p:sldId id="258" r:id="rId4"/>
     <p:sldId id="259" r:id="rId5"/>
     <p:sldId id="260" r:id="rId6"/>
+    <p:sldId id="261" r:id="rId7"/>
   </p:sldIdLst>
   <p:notesMasterIdLst>
-    <p:notesMasterId r:id="rId7"/>
+    <p:notesMasterId r:id="rId8"/>
   </p:notesMasterIdLst>
   <p:sldSz cx="12192000" cy="6858000"/>
   <p:notesSz cx="6858000" cy="12192000"/>
@@ -1400,6 +1401,94 @@
             <a:fld id="{F7021451-1387-4CA6-816F-3879F97B5CBC}" type="slidenum">
               <a:rPr lang="en-US"/>
               <a:t>5</a:t>
+            </a:fld>
+            <a:endParaRPr lang="en-US"/>
+          </a:p>
+        </p:txBody>
+      </p:sp>
+    </p:spTree>
+    <p:extLst>
+      <p:ext uri="{BB962C8B-B14F-4D97-AF65-F5344CB8AC3E}">
+        <p14:creationId xmlns:p14="http://schemas.microsoft.com/office/powerpoint/2010/main" val="1024086991"/>
+      </p:ext>
+    </p:extLst>
+  </p:cSld>
+  <p:clrMapOvr>
+    <a:masterClrMapping/>
+  </p:clrMapOvr>
+</p:notes>
+</file>
+
+<file path=ppt/notesSlides/notesSlide6.xml><?xml version="1.0" encoding="utf-8"?>
+<p:notes xmlns:a="http://schemas.openxmlformats.org/drawingml/2006/main" xmlns:r="http://schemas.openxmlformats.org/officeDocument/2006/relationships" xmlns:p="http://schemas.openxmlformats.org/presentationml/2006/main">
+  <p:cSld>
+    <p:spTree>
+      <p:nvGrpSpPr>
+        <p:cNvPr id="1" name=""/>
+        <p:cNvGrpSpPr/>
+        <p:nvPr/>
+      </p:nvGrpSpPr>
+      <p:grpSpPr>
+        <a:xfrm>
+          <a:off x="0" y="0"/>
+          <a:ext cx="0" cy="0"/>
+          <a:chOff x="0" y="0"/>
+          <a:chExt cx="0" cy="0"/>
+        </a:xfrm>
+      </p:grpSpPr>
+      <p:sp>
+        <p:nvSpPr>
+          <p:cNvPr id="2" name="Slide Image Placeholder 1"/>
+          <p:cNvSpPr>
+            <a:spLocks noGrp="1" noRot="1" noChangeAspect="1"/>
+          </p:cNvSpPr>
+          <p:nvPr>
+            <p:ph type="sldImg"/>
+          </p:nvPr>
+        </p:nvSpPr>
+        <p:spPr/>
+      </p:sp>
+      <p:sp>
+        <p:nvSpPr>
+          <p:cNvPr id="3" name="Notes Placeholder 2"/>
+          <p:cNvSpPr>
+            <a:spLocks noGrp="1"/>
+          </p:cNvSpPr>
+          <p:nvPr>
+            <p:ph type="body" idx="1"/>
+          </p:nvPr>
+        </p:nvSpPr>
+        <p:spPr/>
+        <p:txBody>
+          <a:bodyPr/>
+          <a:lstStyle/>
+          <a:p>
+            <a:r>
+              <a:rPr lang="en-US" dirty="0"/>
+              <a:t/>
+            </a:r>
+            <a:endParaRPr lang="en-US" dirty="0"/>
+          </a:p>
+        </p:txBody>
+      </p:sp>
+      <p:sp>
+        <p:nvSpPr>
+          <p:cNvPr id="4" name="Slide Number Placeholder 3"/>
+          <p:cNvSpPr>
+            <a:spLocks noGrp="1"/>
+          </p:cNvSpPr>
+          <p:nvPr>
+            <p:ph type="sldNum" sz="quarter" idx="10"/>
+          </p:nvPr>
+        </p:nvSpPr>
+        <p:spPr/>
+        <p:txBody>
+          <a:bodyPr/>
+          <a:lstStyle/>
+          <a:p>
+            <a:fld id="{F7021451-1387-4CA6-816F-3879F97B5CBC}" type="slidenum">
+              <a:rPr lang="en-US"/>
+              <a:t>6</a:t>
             </a:fld>
             <a:endParaRPr lang="en-US"/>
           </a:p>
@@ -2648,7 +2737,7 @@
                 <a:ea typeface="Calibri" pitchFamily="34" charset="-122"/>
                 <a:cs typeface="Calibri" pitchFamily="34" charset="-120"/>
               </a:rPr>
-              <a:t>1 / 5</a:t>
+              <a:t>1 / 6</a:t>
             </a:r>
             <a:endParaRPr lang="en-US" sz="900" dirty="0"/>
           </a:p>
@@ -3650,7 +3739,7 @@
                 <a:ea typeface="Calibri" pitchFamily="34" charset="-122"/>
                 <a:cs typeface="Calibri" pitchFamily="34" charset="-120"/>
               </a:rPr>
-              <a:t>2 / 5</a:t>
+              <a:t>2 / 6</a:t>
             </a:r>
             <a:endParaRPr lang="en-US" sz="900" dirty="0"/>
           </a:p>
@@ -4995,7 +5084,7 @@
                 <a:ea typeface="Calibri" pitchFamily="34" charset="-122"/>
                 <a:cs typeface="Calibri" pitchFamily="34" charset="-120"/>
               </a:rPr>
-              <a:t>3 / 5</a:t>
+              <a:t>3 / 6</a:t>
             </a:r>
             <a:endParaRPr lang="en-US" sz="900" dirty="0"/>
           </a:p>
@@ -6331,7 +6420,7 @@
                 <a:ea typeface="Calibri" pitchFamily="34" charset="-122"/>
                 <a:cs typeface="Calibri" pitchFamily="34" charset="-120"/>
               </a:rPr>
-              <a:t>4 / 5</a:t>
+              <a:t>4 / 6</a:t>
             </a:r>
             <a:endParaRPr lang="en-US" sz="900" dirty="0"/>
           </a:p>
@@ -7314,6 +7403,635 @@
               <a:t>Wir starten gemeinsam mit dem Quick-Win-Sprint  ·  eology.de  ·  info@eology.de</a:t>
             </a:r>
             <a:endParaRPr lang="en-US" sz="1000" dirty="0"/>
+          </a:p>
+        </p:txBody>
+      </p:sp>
+    </p:spTree>
+  </p:cSld>
+  <p:clrMapOvr>
+    <a:masterClrMapping/>
+  </p:clrMapOvr>
+</p:sld>
+</file>
+
+<file path=ppt/slides/slide6.xml><?xml version="1.0" encoding="utf-8"?>
+<p:sld xmlns:a="http://schemas.openxmlformats.org/drawingml/2006/main" xmlns:r="http://schemas.openxmlformats.org/officeDocument/2006/relationships" xmlns:p="http://schemas.openxmlformats.org/presentationml/2006/main">
+  <p:cSld name="Slide 6">
+    <p:bg>
+      <p:bgPr>
+        <a:solidFill>
+          <a:srgbClr val="0A1117"/>
+        </a:solidFill>
+      </p:bgPr>
+    </p:bg>
+    <p:spTree>
+      <p:nvGrpSpPr>
+        <p:cNvPr id="1" name=""/>
+        <p:cNvGrpSpPr/>
+        <p:nvPr/>
+      </p:nvGrpSpPr>
+      <p:grpSpPr>
+        <a:xfrm>
+          <a:off x="0" y="0"/>
+          <a:ext cx="0" cy="0"/>
+          <a:chOff x="0" y="0"/>
+          <a:chExt cx="0" cy="0"/>
+        </a:xfrm>
+      </p:grpSpPr>
+      <p:sp>
+        <p:nvSpPr>
+          <p:cNvPr id="2" name="Shape 0"/>
+          <p:cNvSpPr/>
+          <p:nvPr/>
+        </p:nvSpPr>
+        <p:spPr>
+          <a:xfrm>
+            <a:off x="10058400" y="0"/>
+            <a:ext cx="2103120" cy="1371600"/>
+          </a:xfrm>
+          <a:prstGeom prst="line">
+            <a:avLst/>
+          </a:prstGeom>
+          <a:noFill/>
+          <a:ln w="9525">
+            <a:solidFill>
+              <a:srgbClr val="54C7E8">
+                <a:alpha val="40000"/>
+              </a:srgbClr>
+            </a:solidFill>
+            <a:prstDash val="solid"/>
+          </a:ln>
+        </p:spPr>
+      </p:sp>
+      <p:sp>
+        <p:nvSpPr>
+          <p:cNvPr id="3" name="Shape 1"/>
+          <p:cNvSpPr/>
+          <p:nvPr/>
+        </p:nvSpPr>
+        <p:spPr>
+          <a:xfrm>
+            <a:off x="10424160" y="0"/>
+            <a:ext cx="1737360" cy="1097280"/>
+          </a:xfrm>
+          <a:prstGeom prst="line">
+            <a:avLst/>
+          </a:prstGeom>
+          <a:noFill/>
+          <a:ln w="9525">
+            <a:solidFill>
+              <a:srgbClr val="54C7E8">
+                <a:alpha val="25000"/>
+              </a:srgbClr>
+            </a:solidFill>
+            <a:prstDash val="solid"/>
+          </a:ln>
+        </p:spPr>
+      </p:sp>
+      <p:sp>
+        <p:nvSpPr>
+          <p:cNvPr id="4" name="Text 2"/>
+          <p:cNvSpPr/>
+          <p:nvPr/>
+        </p:nvSpPr>
+        <p:spPr>
+          <a:xfrm>
+            <a:off x="457200" y="365760"/>
+            <a:ext cx="1828800" cy="365760"/>
+          </a:xfrm>
+          <a:prstGeom prst="rect">
+            <a:avLst/>
+          </a:prstGeom>
+          <a:noFill/>
+          <a:ln/>
+        </p:spPr>
+        <p:txBody>
+          <a:bodyPr wrap="square" lIns="0" tIns="0" rIns="0" bIns="0" rtlCol="0" anchor="ctr"/>
+          <a:lstStyle/>
+          <a:p>
+            <a:pPr indent="0" marL="0">
+              <a:buNone/>
+            </a:pPr>
+            <a:r>
+              <a:rPr lang="en-US" sz="1600" b="1" dirty="0">
+                <a:solidFill>
+                  <a:srgbClr val="54C7E8"/>
+                </a:solidFill>
+                <a:latin typeface="Calibri" pitchFamily="34" charset="0"/>
+                <a:ea typeface="Calibri" pitchFamily="34" charset="-122"/>
+                <a:cs typeface="Calibri" pitchFamily="34" charset="-120"/>
+              </a:rPr>
+              <a:t>eology</a:t>
+            </a:r>
+            <a:endParaRPr lang="en-US" sz="1600" dirty="0"/>
+          </a:p>
+        </p:txBody>
+      </p:sp>
+      <p:sp>
+        <p:nvSpPr>
+          <p:cNvPr id="5" name="Text 3"/>
+          <p:cNvSpPr/>
+          <p:nvPr/>
+        </p:nvSpPr>
+        <p:spPr>
+          <a:xfrm>
+            <a:off x="457200" y="685800"/>
+            <a:ext cx="5486400" cy="274320"/>
+          </a:xfrm>
+          <a:prstGeom prst="rect">
+            <a:avLst/>
+          </a:prstGeom>
+          <a:noFill/>
+          <a:ln/>
+        </p:spPr>
+        <p:txBody>
+          <a:bodyPr wrap="square" lIns="0" tIns="0" rIns="0" bIns="0" rtlCol="0" anchor="ctr"/>
+          <a:lstStyle/>
+          <a:p>
+            <a:pPr indent="0" marL="0">
+              <a:buNone/>
+            </a:pPr>
+            <a:r>
+              <a:rPr lang="en-US" sz="1000" i="1" dirty="0">
+                <a:solidFill>
+                  <a:srgbClr val="D7DDE0"/>
+                </a:solidFill>
+                <a:latin typeface="Calibri" pitchFamily="34" charset="0"/>
+                <a:ea typeface="Calibri" pitchFamily="34" charset="-122"/>
+                <a:cs typeface="Calibri" pitchFamily="34" charset="-120"/>
+              </a:rPr>
+              <a:t>Your AI-driven Online Marketing Agency</a:t>
+            </a:r>
+            <a:endParaRPr lang="en-US" sz="1000" dirty="0"/>
+          </a:p>
+        </p:txBody>
+      </p:sp>
+      <p:sp>
+        <p:nvSpPr>
+          <p:cNvPr id="6" name="Shape 4"/>
+          <p:cNvSpPr/>
+          <p:nvPr/>
+        </p:nvSpPr>
+        <p:spPr>
+          <a:xfrm>
+            <a:off x="457200" y="1737360"/>
+            <a:ext cx="2743200" cy="411480"/>
+          </a:xfrm>
+          <a:prstGeom prst="roundRect">
+            <a:avLst>
+              <a:gd name="adj" fmla="val 17778"/>
+            </a:avLst>
+          </a:prstGeom>
+          <a:solidFill>
+            <a:srgbClr val="54C7E8">
+              <a:alpha val="20000"/>
+            </a:srgbClr>
+          </a:solidFill>
+          <a:ln w="12700">
+            <a:solidFill>
+              <a:srgbClr val="54C7E8"/>
+            </a:solidFill>
+            <a:prstDash val="solid"/>
+          </a:ln>
+        </p:spPr>
+      </p:sp>
+      <p:sp>
+        <p:nvSpPr>
+          <p:cNvPr id="7" name="Text 5"/>
+          <p:cNvSpPr/>
+          <p:nvPr/>
+        </p:nvSpPr>
+        <p:spPr>
+          <a:xfrm>
+            <a:off x="457200" y="1737360"/>
+            <a:ext cx="2743200" cy="411480"/>
+          </a:xfrm>
+          <a:prstGeom prst="rect">
+            <a:avLst/>
+          </a:prstGeom>
+          <a:noFill/>
+          <a:ln/>
+        </p:spPr>
+        <p:txBody>
+          <a:bodyPr wrap="square" lIns="0" tIns="0" rIns="0" bIns="0" rtlCol="0" anchor="ctr"/>
+          <a:lstStyle/>
+          <a:p>
+            <a:pPr algn="ctr" indent="0" marL="0">
+              <a:buNone/>
+            </a:pPr>
+            <a:r>
+              <a:rPr lang="en-US" sz="1100" b="1" spc="300" kern="0" dirty="0">
+                <a:solidFill>
+                  <a:srgbClr val="54C7E8"/>
+                </a:solidFill>
+                <a:latin typeface="Calibri" pitchFamily="34" charset="0"/>
+                <a:ea typeface="Calibri" pitchFamily="34" charset="-122"/>
+                <a:cs typeface="Calibri" pitchFamily="34" charset="-120"/>
+              </a:rPr>
+              <a:t>IHR ANSPRECHPARTNER</a:t>
+            </a:r>
+            <a:endParaRPr lang="en-US" sz="1100" dirty="0"/>
+          </a:p>
+        </p:txBody>
+      </p:sp>
+      <p:sp>
+        <p:nvSpPr>
+          <p:cNvPr id="8" name="Text 6"/>
+          <p:cNvSpPr/>
+          <p:nvPr/>
+        </p:nvSpPr>
+        <p:spPr>
+          <a:xfrm>
+            <a:off x="457200" y="2286000"/>
+            <a:ext cx="10972800" cy="1005840"/>
+          </a:xfrm>
+          <a:prstGeom prst="rect">
+            <a:avLst/>
+          </a:prstGeom>
+          <a:noFill/>
+          <a:ln/>
+        </p:spPr>
+        <p:txBody>
+          <a:bodyPr wrap="square" lIns="0" tIns="0" rIns="0" bIns="0" rtlCol="0" anchor="ctr"/>
+          <a:lstStyle/>
+          <a:p>
+            <a:pPr indent="0" marL="0">
+              <a:buNone/>
+            </a:pPr>
+            <a:r>
+              <a:rPr lang="en-US" sz="6000" b="1" dirty="0">
+                <a:solidFill>
+                  <a:srgbClr val="FFFFFF"/>
+                </a:solidFill>
+                <a:latin typeface="Calibri" pitchFamily="34" charset="0"/>
+                <a:ea typeface="Calibri" pitchFamily="34" charset="-122"/>
+                <a:cs typeface="Calibri" pitchFamily="34" charset="-120"/>
+              </a:rPr>
+              <a:t>MARIO STRACK</a:t>
+            </a:r>
+            <a:endParaRPr lang="en-US" sz="6000" dirty="0"/>
+          </a:p>
+        </p:txBody>
+      </p:sp>
+      <p:sp>
+        <p:nvSpPr>
+          <p:cNvPr id="9" name="Text 7"/>
+          <p:cNvSpPr/>
+          <p:nvPr/>
+        </p:nvSpPr>
+        <p:spPr>
+          <a:xfrm>
+            <a:off x="457200" y="3337560"/>
+            <a:ext cx="10972800" cy="502920"/>
+          </a:xfrm>
+          <a:prstGeom prst="rect">
+            <a:avLst/>
+          </a:prstGeom>
+          <a:noFill/>
+          <a:ln/>
+        </p:spPr>
+        <p:txBody>
+          <a:bodyPr wrap="square" lIns="0" tIns="0" rIns="0" bIns="0" rtlCol="0" anchor="ctr"/>
+          <a:lstStyle/>
+          <a:p>
+            <a:pPr indent="0" marL="0">
+              <a:buNone/>
+            </a:pPr>
+            <a:r>
+              <a:rPr lang="en-US" sz="2400" spc="200" kern="0" dirty="0">
+                <a:solidFill>
+                  <a:srgbClr val="54C7E8"/>
+                </a:solidFill>
+                <a:latin typeface="Calibri" pitchFamily="34" charset="0"/>
+                <a:ea typeface="Calibri" pitchFamily="34" charset="-122"/>
+                <a:cs typeface="Calibri" pitchFamily="34" charset="-120"/>
+              </a:rPr>
+              <a:t>CGO  –  Chief Growth Officer</a:t>
+            </a:r>
+            <a:endParaRPr lang="en-US" sz="2400" dirty="0"/>
+          </a:p>
+        </p:txBody>
+      </p:sp>
+      <p:sp>
+        <p:nvSpPr>
+          <p:cNvPr id="10" name="Shape 8"/>
+          <p:cNvSpPr/>
+          <p:nvPr/>
+        </p:nvSpPr>
+        <p:spPr>
+          <a:xfrm>
+            <a:off x="457200" y="4114800"/>
+            <a:ext cx="1097280" cy="0"/>
+          </a:xfrm>
+          <a:prstGeom prst="line">
+            <a:avLst/>
+          </a:prstGeom>
+          <a:noFill/>
+          <a:ln w="38100">
+            <a:solidFill>
+              <a:srgbClr val="54C7E8"/>
+            </a:solidFill>
+            <a:prstDash val="solid"/>
+          </a:ln>
+        </p:spPr>
+      </p:sp>
+      <p:sp>
+        <p:nvSpPr>
+          <p:cNvPr id="11" name="Text 9"/>
+          <p:cNvSpPr/>
+          <p:nvPr/>
+        </p:nvSpPr>
+        <p:spPr>
+          <a:xfrm>
+            <a:off x="457200" y="4389120"/>
+            <a:ext cx="3657600" cy="274320"/>
+          </a:xfrm>
+          <a:prstGeom prst="rect">
+            <a:avLst/>
+          </a:prstGeom>
+          <a:noFill/>
+          <a:ln/>
+        </p:spPr>
+        <p:txBody>
+          <a:bodyPr wrap="square" lIns="0" tIns="0" rIns="0" bIns="0" rtlCol="0" anchor="ctr"/>
+          <a:lstStyle/>
+          <a:p>
+            <a:pPr indent="0" marL="0">
+              <a:buNone/>
+            </a:pPr>
+            <a:r>
+              <a:rPr lang="en-US" sz="1000" b="1" spc="300" kern="0" dirty="0">
+                <a:solidFill>
+                  <a:srgbClr val="54C7E8"/>
+                </a:solidFill>
+                <a:latin typeface="Calibri" pitchFamily="34" charset="0"/>
+                <a:ea typeface="Calibri" pitchFamily="34" charset="-122"/>
+                <a:cs typeface="Calibri" pitchFamily="34" charset="-120"/>
+              </a:rPr>
+              <a:t>TELEFON</a:t>
+            </a:r>
+            <a:endParaRPr lang="en-US" sz="1000" dirty="0"/>
+          </a:p>
+        </p:txBody>
+      </p:sp>
+      <p:sp>
+        <p:nvSpPr>
+          <p:cNvPr id="12" name="Text 10"/>
+          <p:cNvSpPr/>
+          <p:nvPr/>
+        </p:nvSpPr>
+        <p:spPr>
+          <a:xfrm>
+            <a:off x="457200" y="4663440"/>
+            <a:ext cx="3657600" cy="457200"/>
+          </a:xfrm>
+          <a:prstGeom prst="rect">
+            <a:avLst/>
+          </a:prstGeom>
+          <a:noFill/>
+          <a:ln/>
+        </p:spPr>
+        <p:txBody>
+          <a:bodyPr wrap="square" lIns="0" tIns="0" rIns="0" bIns="0" rtlCol="0" anchor="ctr"/>
+          <a:lstStyle/>
+          <a:p>
+            <a:pPr indent="0" marL="0">
+              <a:buNone/>
+            </a:pPr>
+            <a:r>
+              <a:rPr lang="en-US" sz="2200" b="1" dirty="0">
+                <a:solidFill>
+                  <a:srgbClr val="FFFFFF"/>
+                </a:solidFill>
+                <a:latin typeface="Calibri" pitchFamily="34" charset="0"/>
+                <a:ea typeface="Calibri" pitchFamily="34" charset="-122"/>
+                <a:cs typeface="Calibri" pitchFamily="34" charset="-120"/>
+              </a:rPr>
+              <a:t>+49 9381 58290 26</a:t>
+            </a:r>
+            <a:endParaRPr lang="en-US" sz="2200" dirty="0"/>
+          </a:p>
+        </p:txBody>
+      </p:sp>
+      <p:sp>
+        <p:nvSpPr>
+          <p:cNvPr id="13" name="Text 11"/>
+          <p:cNvSpPr/>
+          <p:nvPr/>
+        </p:nvSpPr>
+        <p:spPr>
+          <a:xfrm>
+            <a:off x="4297680" y="4389120"/>
+            <a:ext cx="3657600" cy="274320"/>
+          </a:xfrm>
+          <a:prstGeom prst="rect">
+            <a:avLst/>
+          </a:prstGeom>
+          <a:noFill/>
+          <a:ln/>
+        </p:spPr>
+        <p:txBody>
+          <a:bodyPr wrap="square" lIns="0" tIns="0" rIns="0" bIns="0" rtlCol="0" anchor="ctr"/>
+          <a:lstStyle/>
+          <a:p>
+            <a:pPr indent="0" marL="0">
+              <a:buNone/>
+            </a:pPr>
+            <a:r>
+              <a:rPr lang="en-US" sz="1000" b="1" spc="300" kern="0" dirty="0">
+                <a:solidFill>
+                  <a:srgbClr val="54C7E8"/>
+                </a:solidFill>
+                <a:latin typeface="Calibri" pitchFamily="34" charset="0"/>
+                <a:ea typeface="Calibri" pitchFamily="34" charset="-122"/>
+                <a:cs typeface="Calibri" pitchFamily="34" charset="-120"/>
+              </a:rPr>
+              <a:t>WEB</a:t>
+            </a:r>
+            <a:endParaRPr lang="en-US" sz="1000" dirty="0"/>
+          </a:p>
+        </p:txBody>
+      </p:sp>
+      <p:sp>
+        <p:nvSpPr>
+          <p:cNvPr id="14" name="Text 12"/>
+          <p:cNvSpPr/>
+          <p:nvPr/>
+        </p:nvSpPr>
+        <p:spPr>
+          <a:xfrm>
+            <a:off x="4297680" y="4663440"/>
+            <a:ext cx="3657600" cy="457200"/>
+          </a:xfrm>
+          <a:prstGeom prst="rect">
+            <a:avLst/>
+          </a:prstGeom>
+          <a:noFill/>
+          <a:ln/>
+        </p:spPr>
+        <p:txBody>
+          <a:bodyPr wrap="square" lIns="0" tIns="0" rIns="0" bIns="0" rtlCol="0" anchor="ctr"/>
+          <a:lstStyle/>
+          <a:p>
+            <a:pPr indent="0" marL="0">
+              <a:buNone/>
+            </a:pPr>
+            <a:r>
+              <a:rPr lang="en-US" sz="2200" b="1" dirty="0">
+                <a:solidFill>
+                  <a:srgbClr val="FFFFFF"/>
+                </a:solidFill>
+                <a:latin typeface="Calibri" pitchFamily="34" charset="0"/>
+                <a:ea typeface="Calibri" pitchFamily="34" charset="-122"/>
+                <a:cs typeface="Calibri" pitchFamily="34" charset="-120"/>
+              </a:rPr>
+              <a:t>eology.de</a:t>
+            </a:r>
+            <a:endParaRPr lang="en-US" sz="2200" dirty="0"/>
+          </a:p>
+        </p:txBody>
+      </p:sp>
+      <p:sp>
+        <p:nvSpPr>
+          <p:cNvPr id="15" name="Text 13"/>
+          <p:cNvSpPr/>
+          <p:nvPr/>
+        </p:nvSpPr>
+        <p:spPr>
+          <a:xfrm>
+            <a:off x="8138160" y="4389120"/>
+            <a:ext cx="3657600" cy="274320"/>
+          </a:xfrm>
+          <a:prstGeom prst="rect">
+            <a:avLst/>
+          </a:prstGeom>
+          <a:noFill/>
+          <a:ln/>
+        </p:spPr>
+        <p:txBody>
+          <a:bodyPr wrap="square" lIns="0" tIns="0" rIns="0" bIns="0" rtlCol="0" anchor="ctr"/>
+          <a:lstStyle/>
+          <a:p>
+            <a:pPr indent="0" marL="0">
+              <a:buNone/>
+            </a:pPr>
+            <a:r>
+              <a:rPr lang="en-US" sz="1000" b="1" spc="300" kern="0" dirty="0">
+                <a:solidFill>
+                  <a:srgbClr val="54C7E8"/>
+                </a:solidFill>
+                <a:latin typeface="Calibri" pitchFamily="34" charset="0"/>
+                <a:ea typeface="Calibri" pitchFamily="34" charset="-122"/>
+                <a:cs typeface="Calibri" pitchFamily="34" charset="-120"/>
+              </a:rPr>
+              <a:t>STANDORT</a:t>
+            </a:r>
+            <a:endParaRPr lang="en-US" sz="1000" dirty="0"/>
+          </a:p>
+        </p:txBody>
+      </p:sp>
+      <p:sp>
+        <p:nvSpPr>
+          <p:cNvPr id="16" name="Text 14"/>
+          <p:cNvSpPr/>
+          <p:nvPr/>
+        </p:nvSpPr>
+        <p:spPr>
+          <a:xfrm>
+            <a:off x="8138160" y="4663440"/>
+            <a:ext cx="4023360" cy="457200"/>
+          </a:xfrm>
+          <a:prstGeom prst="rect">
+            <a:avLst/>
+          </a:prstGeom>
+          <a:noFill/>
+          <a:ln/>
+        </p:spPr>
+        <p:txBody>
+          <a:bodyPr wrap="square" lIns="0" tIns="0" rIns="0" bIns="0" rtlCol="0" anchor="ctr"/>
+          <a:lstStyle/>
+          <a:p>
+            <a:pPr indent="0" marL="0">
+              <a:buNone/>
+            </a:pPr>
+            <a:r>
+              <a:rPr lang="en-US" sz="1600" b="1" dirty="0">
+                <a:solidFill>
+                  <a:srgbClr val="FFFFFF"/>
+                </a:solidFill>
+                <a:latin typeface="Calibri" pitchFamily="34" charset="0"/>
+                <a:ea typeface="Calibri" pitchFamily="34" charset="-122"/>
+                <a:cs typeface="Calibri" pitchFamily="34" charset="-120"/>
+              </a:rPr>
+              <a:t>Volkach · Würzburg · Hamburg</a:t>
+            </a:r>
+            <a:endParaRPr lang="en-US" sz="1600" dirty="0"/>
+          </a:p>
+        </p:txBody>
+      </p:sp>
+      <p:sp>
+        <p:nvSpPr>
+          <p:cNvPr id="17" name="Shape 15"/>
+          <p:cNvSpPr/>
+          <p:nvPr/>
+        </p:nvSpPr>
+        <p:spPr>
+          <a:xfrm>
+            <a:off x="457200" y="6080760"/>
+            <a:ext cx="11247120" cy="365760"/>
+          </a:xfrm>
+          <a:prstGeom prst="roundRect">
+            <a:avLst>
+              <a:gd name="adj" fmla="val 12500"/>
+            </a:avLst>
+          </a:prstGeom>
+          <a:solidFill>
+            <a:srgbClr val="54C7E8"/>
+          </a:solidFill>
+          <a:ln w="12700">
+            <a:solidFill>
+              <a:srgbClr val="54C7E8"/>
+            </a:solidFill>
+            <a:prstDash val="solid"/>
+          </a:ln>
+        </p:spPr>
+      </p:sp>
+      <p:sp>
+        <p:nvSpPr>
+          <p:cNvPr id="18" name="Text 16"/>
+          <p:cNvSpPr/>
+          <p:nvPr/>
+        </p:nvSpPr>
+        <p:spPr>
+          <a:xfrm>
+            <a:off x="457200" y="6080760"/>
+            <a:ext cx="11247120" cy="365760"/>
+          </a:xfrm>
+          <a:prstGeom prst="rect">
+            <a:avLst/>
+          </a:prstGeom>
+          <a:noFill/>
+          <a:ln/>
+        </p:spPr>
+        <p:txBody>
+          <a:bodyPr wrap="square" lIns="0" tIns="0" rIns="0" bIns="0" rtlCol="0" anchor="ctr"/>
+          <a:lstStyle/>
+          <a:p>
+            <a:pPr algn="ctr" indent="0" marL="0">
+              <a:buNone/>
+            </a:pPr>
+            <a:r>
+              <a:rPr lang="en-US" sz="1200" b="1" dirty="0">
+                <a:solidFill>
+                  <a:srgbClr val="0A1117"/>
+                </a:solidFill>
+                <a:latin typeface="Calibri" pitchFamily="34" charset="0"/>
+                <a:ea typeface="Calibri" pitchFamily="34" charset="-122"/>
+                <a:cs typeface="Calibri" pitchFamily="34" charset="-120"/>
+              </a:rPr>
+              <a:t>Let's rock together — wir freuen uns auf die Sparkasse Düren.</a:t>
+            </a:r>
+            <a:endParaRPr lang="en-US" sz="1200" dirty="0"/>
           </a:p>
         </p:txBody>
       </p:sp>

</xml_diff>

<commit_message>
sparkasse-dueren: Kontaktfolie mit Foto Mario Strack + E-Mail
- Foto von eology.de Team-Seite gezogen (Mario_Website_schwarz.jpg)
- E-Mail m.strack@eology.de nach eology-Namenskonvention

Co-Authored-By: Claude Opus 4.7 <noreply@anthropic.com>
Claude-Session: https://claude.ai/code/session_019JdfnJd2Mr6vK4FK3ePtt7
</commit_message>
<xml_diff>
--- a/kunden/sparkasse-dueren/decks/sparkasse_dueren_pitch.pptx
+++ b/kunden/sparkasse-dueren/decks/sparkasse_dueren_pitch.pptx
@@ -7574,7 +7574,60 @@
         </p:nvSpPr>
         <p:spPr>
           <a:xfrm>
-            <a:off x="457200" y="1737360"/>
+            <a:off x="548640" y="1554480"/>
+            <a:ext cx="3840480" cy="3840480"/>
+          </a:xfrm>
+          <a:prstGeom prst="roundRect">
+            <a:avLst>
+              <a:gd name="adj" fmla="val 3571"/>
+            </a:avLst>
+          </a:prstGeom>
+          <a:solidFill>
+            <a:srgbClr val="54C7E8">
+              <a:alpha val="30000"/>
+            </a:srgbClr>
+          </a:solidFill>
+          <a:ln w="12700">
+            <a:solidFill>
+              <a:srgbClr val="54C7E8"/>
+            </a:solidFill>
+            <a:prstDash val="solid"/>
+          </a:ln>
+        </p:spPr>
+      </p:sp>
+      <p:pic>
+        <p:nvPicPr>
+          <p:cNvPr id="7" name="Image 0" descr="/home/user/claude-recherche/kunden/sparkasse-dueren/decks/mario_strack.jpg">    </p:cNvPr>
+          <p:cNvPicPr>
+            <a:picLocks noChangeAspect="1"/>
+          </p:cNvPicPr>
+          <p:nvPr/>
+        </p:nvPicPr>
+        <p:blipFill>
+          <a:blip r:embed="rId1"/>
+          <a:stretch>
+            <a:fillRect/>
+          </a:stretch>
+        </p:blipFill>
+        <p:spPr>
+          <a:xfrm>
+            <a:off x="640080" y="1645920"/>
+            <a:ext cx="3657600" cy="3657600"/>
+          </a:xfrm>
+          <a:prstGeom prst="ellipse">
+            <a:avLst/>
+          </a:prstGeom>
+        </p:spPr>
+      </p:pic>
+      <p:sp>
+        <p:nvSpPr>
+          <p:cNvPr id="8" name="Shape 5"/>
+          <p:cNvSpPr/>
+          <p:nvPr/>
+        </p:nvSpPr>
+        <p:spPr>
+          <a:xfrm>
+            <a:off x="4754880" y="1691640"/>
             <a:ext cx="2743200" cy="411480"/>
           </a:xfrm>
           <a:prstGeom prst="roundRect">
@@ -7597,13 +7650,13 @@
       </p:sp>
       <p:sp>
         <p:nvSpPr>
-          <p:cNvPr id="7" name="Text 5"/>
-          <p:cNvSpPr/>
-          <p:nvPr/>
-        </p:nvSpPr>
-        <p:spPr>
-          <a:xfrm>
-            <a:off x="457200" y="1737360"/>
+          <p:cNvPr id="9" name="Text 6"/>
+          <p:cNvSpPr/>
+          <p:nvPr/>
+        </p:nvSpPr>
+        <p:spPr>
+          <a:xfrm>
+            <a:off x="4754880" y="1691640"/>
             <a:ext cx="2743200" cy="411480"/>
           </a:xfrm>
           <a:prstGeom prst="rect">
@@ -7636,30 +7689,30 @@
       </p:sp>
       <p:sp>
         <p:nvSpPr>
-          <p:cNvPr id="8" name="Text 6"/>
-          <p:cNvSpPr/>
-          <p:nvPr/>
-        </p:nvSpPr>
-        <p:spPr>
-          <a:xfrm>
-            <a:off x="457200" y="2286000"/>
-            <a:ext cx="10972800" cy="1005840"/>
-          </a:xfrm>
-          <a:prstGeom prst="rect">
-            <a:avLst/>
-          </a:prstGeom>
-          <a:noFill/>
-          <a:ln/>
-        </p:spPr>
-        <p:txBody>
-          <a:bodyPr wrap="square" lIns="0" tIns="0" rIns="0" bIns="0" rtlCol="0" anchor="ctr"/>
-          <a:lstStyle/>
-          <a:p>
-            <a:pPr indent="0" marL="0">
-              <a:buNone/>
-            </a:pPr>
-            <a:r>
-              <a:rPr lang="en-US" sz="6000" b="1" dirty="0">
+          <p:cNvPr id="10" name="Text 7"/>
+          <p:cNvSpPr/>
+          <p:nvPr/>
+        </p:nvSpPr>
+        <p:spPr>
+          <a:xfrm>
+            <a:off x="4754880" y="2286000"/>
+            <a:ext cx="6949440" cy="914400"/>
+          </a:xfrm>
+          <a:prstGeom prst="rect">
+            <a:avLst/>
+          </a:prstGeom>
+          <a:noFill/>
+          <a:ln/>
+        </p:spPr>
+        <p:txBody>
+          <a:bodyPr wrap="square" lIns="0" tIns="0" rIns="0" bIns="0" rtlCol="0" anchor="ctr"/>
+          <a:lstStyle/>
+          <a:p>
+            <a:pPr indent="0" marL="0">
+              <a:buNone/>
+            </a:pPr>
+            <a:r>
+              <a:rPr lang="en-US" sz="4800" b="1" dirty="0">
                 <a:solidFill>
                   <a:srgbClr val="FFFFFF"/>
                 </a:solidFill>
@@ -7669,36 +7722,36 @@
               </a:rPr>
               <a:t>MARIO STRACK</a:t>
             </a:r>
-            <a:endParaRPr lang="en-US" sz="6000" dirty="0"/>
-          </a:p>
-        </p:txBody>
-      </p:sp>
-      <p:sp>
-        <p:nvSpPr>
-          <p:cNvPr id="9" name="Text 7"/>
-          <p:cNvSpPr/>
-          <p:nvPr/>
-        </p:nvSpPr>
-        <p:spPr>
-          <a:xfrm>
-            <a:off x="457200" y="3337560"/>
-            <a:ext cx="10972800" cy="502920"/>
-          </a:xfrm>
-          <a:prstGeom prst="rect">
-            <a:avLst/>
-          </a:prstGeom>
-          <a:noFill/>
-          <a:ln/>
-        </p:spPr>
-        <p:txBody>
-          <a:bodyPr wrap="square" lIns="0" tIns="0" rIns="0" bIns="0" rtlCol="0" anchor="ctr"/>
-          <a:lstStyle/>
-          <a:p>
-            <a:pPr indent="0" marL="0">
-              <a:buNone/>
-            </a:pPr>
-            <a:r>
-              <a:rPr lang="en-US" sz="2400" spc="200" kern="0" dirty="0">
+            <a:endParaRPr lang="en-US" sz="4800" dirty="0"/>
+          </a:p>
+        </p:txBody>
+      </p:sp>
+      <p:sp>
+        <p:nvSpPr>
+          <p:cNvPr id="11" name="Text 8"/>
+          <p:cNvSpPr/>
+          <p:nvPr/>
+        </p:nvSpPr>
+        <p:spPr>
+          <a:xfrm>
+            <a:off x="4754880" y="3200400"/>
+            <a:ext cx="6949440" cy="457200"/>
+          </a:xfrm>
+          <a:prstGeom prst="rect">
+            <a:avLst/>
+          </a:prstGeom>
+          <a:noFill/>
+          <a:ln/>
+        </p:spPr>
+        <p:txBody>
+          <a:bodyPr wrap="square" lIns="0" tIns="0" rIns="0" bIns="0" rtlCol="0" anchor="ctr"/>
+          <a:lstStyle/>
+          <a:p>
+            <a:pPr indent="0" marL="0">
+              <a:buNone/>
+            </a:pPr>
+            <a:r>
+              <a:rPr lang="en-US" sz="2000" spc="200" kern="0" dirty="0">
                 <a:solidFill>
                   <a:srgbClr val="54C7E8"/>
                 </a:solidFill>
@@ -7708,19 +7761,19 @@
               </a:rPr>
               <a:t>CGO  –  Chief Growth Officer</a:t>
             </a:r>
-            <a:endParaRPr lang="en-US" sz="2400" dirty="0"/>
-          </a:p>
-        </p:txBody>
-      </p:sp>
-      <p:sp>
-        <p:nvSpPr>
-          <p:cNvPr id="10" name="Shape 8"/>
-          <p:cNvSpPr/>
-          <p:nvPr/>
-        </p:nvSpPr>
-        <p:spPr>
-          <a:xfrm>
-            <a:off x="457200" y="4114800"/>
+            <a:endParaRPr lang="en-US" sz="2000" dirty="0"/>
+          </a:p>
+        </p:txBody>
+      </p:sp>
+      <p:sp>
+        <p:nvSpPr>
+          <p:cNvPr id="12" name="Shape 9"/>
+          <p:cNvSpPr/>
+          <p:nvPr/>
+        </p:nvSpPr>
+        <p:spPr>
+          <a:xfrm>
+            <a:off x="4754880" y="3794760"/>
             <a:ext cx="1097280" cy="0"/>
           </a:xfrm>
           <a:prstGeom prst="line">
@@ -7737,30 +7790,30 @@
       </p:sp>
       <p:sp>
         <p:nvSpPr>
-          <p:cNvPr id="11" name="Text 9"/>
-          <p:cNvSpPr/>
-          <p:nvPr/>
-        </p:nvSpPr>
-        <p:spPr>
-          <a:xfrm>
-            <a:off x="457200" y="4389120"/>
-            <a:ext cx="3657600" cy="274320"/>
-          </a:xfrm>
-          <a:prstGeom prst="rect">
-            <a:avLst/>
-          </a:prstGeom>
-          <a:noFill/>
-          <a:ln/>
-        </p:spPr>
-        <p:txBody>
-          <a:bodyPr wrap="square" lIns="0" tIns="0" rIns="0" bIns="0" rtlCol="0" anchor="ctr"/>
-          <a:lstStyle/>
-          <a:p>
-            <a:pPr indent="0" marL="0">
-              <a:buNone/>
-            </a:pPr>
-            <a:r>
-              <a:rPr lang="en-US" sz="1000" b="1" spc="300" kern="0" dirty="0">
+          <p:cNvPr id="13" name="Text 10"/>
+          <p:cNvSpPr/>
+          <p:nvPr/>
+        </p:nvSpPr>
+        <p:spPr>
+          <a:xfrm>
+            <a:off x="4754880" y="4023360"/>
+            <a:ext cx="320040" cy="502920"/>
+          </a:xfrm>
+          <a:prstGeom prst="rect">
+            <a:avLst/>
+          </a:prstGeom>
+          <a:noFill/>
+          <a:ln/>
+        </p:spPr>
+        <p:txBody>
+          <a:bodyPr wrap="square" lIns="0" tIns="0" rIns="0" bIns="0" rtlCol="0" anchor="ctr"/>
+          <a:lstStyle/>
+          <a:p>
+            <a:pPr indent="0" marL="0">
+              <a:buNone/>
+            </a:pPr>
+            <a:r>
+              <a:rPr lang="en-US" sz="1200" b="1" dirty="0">
                 <a:solidFill>
                   <a:srgbClr val="54C7E8"/>
                 </a:solidFill>
@@ -7768,38 +7821,38 @@
                 <a:ea typeface="Calibri" pitchFamily="34" charset="-122"/>
                 <a:cs typeface="Calibri" pitchFamily="34" charset="-120"/>
               </a:rPr>
-              <a:t>TELEFON</a:t>
-            </a:r>
-            <a:endParaRPr lang="en-US" sz="1000" dirty="0"/>
-          </a:p>
-        </p:txBody>
-      </p:sp>
-      <p:sp>
-        <p:nvSpPr>
-          <p:cNvPr id="12" name="Text 10"/>
-          <p:cNvSpPr/>
-          <p:nvPr/>
-        </p:nvSpPr>
-        <p:spPr>
-          <a:xfrm>
-            <a:off x="457200" y="4663440"/>
-            <a:ext cx="3657600" cy="457200"/>
-          </a:xfrm>
-          <a:prstGeom prst="rect">
-            <a:avLst/>
-          </a:prstGeom>
-          <a:noFill/>
-          <a:ln/>
-        </p:spPr>
-        <p:txBody>
-          <a:bodyPr wrap="square" lIns="0" tIns="0" rIns="0" bIns="0" rtlCol="0" anchor="ctr"/>
-          <a:lstStyle/>
-          <a:p>
-            <a:pPr indent="0" marL="0">
-              <a:buNone/>
-            </a:pPr>
-            <a:r>
-              <a:rPr lang="en-US" sz="2200" b="1" dirty="0">
+              <a:t>T</a:t>
+            </a:r>
+            <a:endParaRPr lang="en-US" sz="1200" dirty="0"/>
+          </a:p>
+        </p:txBody>
+      </p:sp>
+      <p:sp>
+        <p:nvSpPr>
+          <p:cNvPr id="14" name="Text 11"/>
+          <p:cNvSpPr/>
+          <p:nvPr/>
+        </p:nvSpPr>
+        <p:spPr>
+          <a:xfrm>
+            <a:off x="5120640" y="4023360"/>
+            <a:ext cx="6583680" cy="502920"/>
+          </a:xfrm>
+          <a:prstGeom prst="rect">
+            <a:avLst/>
+          </a:prstGeom>
+          <a:noFill/>
+          <a:ln/>
+        </p:spPr>
+        <p:txBody>
+          <a:bodyPr wrap="square" lIns="0" tIns="0" rIns="0" bIns="0" rtlCol="0" anchor="ctr"/>
+          <a:lstStyle/>
+          <a:p>
+            <a:pPr indent="0" marL="0">
+              <a:buNone/>
+            </a:pPr>
+            <a:r>
+              <a:rPr lang="en-US" sz="1800" b="1" dirty="0">
                 <a:solidFill>
                   <a:srgbClr val="FFFFFF"/>
                 </a:solidFill>
@@ -7809,36 +7862,36 @@
               </a:rPr>
               <a:t>+49 9381 58290 26</a:t>
             </a:r>
-            <a:endParaRPr lang="en-US" sz="2200" dirty="0"/>
-          </a:p>
-        </p:txBody>
-      </p:sp>
-      <p:sp>
-        <p:nvSpPr>
-          <p:cNvPr id="13" name="Text 11"/>
-          <p:cNvSpPr/>
-          <p:nvPr/>
-        </p:nvSpPr>
-        <p:spPr>
-          <a:xfrm>
-            <a:off x="4297680" y="4389120"/>
-            <a:ext cx="3657600" cy="274320"/>
-          </a:xfrm>
-          <a:prstGeom prst="rect">
-            <a:avLst/>
-          </a:prstGeom>
-          <a:noFill/>
-          <a:ln/>
-        </p:spPr>
-        <p:txBody>
-          <a:bodyPr wrap="square" lIns="0" tIns="0" rIns="0" bIns="0" rtlCol="0" anchor="ctr"/>
-          <a:lstStyle/>
-          <a:p>
-            <a:pPr indent="0" marL="0">
-              <a:buNone/>
-            </a:pPr>
-            <a:r>
-              <a:rPr lang="en-US" sz="1000" b="1" spc="300" kern="0" dirty="0">
+            <a:endParaRPr lang="en-US" sz="1800" dirty="0"/>
+          </a:p>
+        </p:txBody>
+      </p:sp>
+      <p:sp>
+        <p:nvSpPr>
+          <p:cNvPr id="15" name="Text 12"/>
+          <p:cNvSpPr/>
+          <p:nvPr/>
+        </p:nvSpPr>
+        <p:spPr>
+          <a:xfrm>
+            <a:off x="4754880" y="4526280"/>
+            <a:ext cx="320040" cy="502920"/>
+          </a:xfrm>
+          <a:prstGeom prst="rect">
+            <a:avLst/>
+          </a:prstGeom>
+          <a:noFill/>
+          <a:ln/>
+        </p:spPr>
+        <p:txBody>
+          <a:bodyPr wrap="square" lIns="0" tIns="0" rIns="0" bIns="0" rtlCol="0" anchor="ctr"/>
+          <a:lstStyle/>
+          <a:p>
+            <a:pPr indent="0" marL="0">
+              <a:buNone/>
+            </a:pPr>
+            <a:r>
+              <a:rPr lang="en-US" sz="1200" b="1" dirty="0">
                 <a:solidFill>
                   <a:srgbClr val="54C7E8"/>
                 </a:solidFill>
@@ -7846,38 +7899,38 @@
                 <a:ea typeface="Calibri" pitchFamily="34" charset="-122"/>
                 <a:cs typeface="Calibri" pitchFamily="34" charset="-120"/>
               </a:rPr>
-              <a:t>WEB</a:t>
-            </a:r>
-            <a:endParaRPr lang="en-US" sz="1000" dirty="0"/>
-          </a:p>
-        </p:txBody>
-      </p:sp>
-      <p:sp>
-        <p:nvSpPr>
-          <p:cNvPr id="14" name="Text 12"/>
-          <p:cNvSpPr/>
-          <p:nvPr/>
-        </p:nvSpPr>
-        <p:spPr>
-          <a:xfrm>
-            <a:off x="4297680" y="4663440"/>
-            <a:ext cx="3657600" cy="457200"/>
-          </a:xfrm>
-          <a:prstGeom prst="rect">
-            <a:avLst/>
-          </a:prstGeom>
-          <a:noFill/>
-          <a:ln/>
-        </p:spPr>
-        <p:txBody>
-          <a:bodyPr wrap="square" lIns="0" tIns="0" rIns="0" bIns="0" rtlCol="0" anchor="ctr"/>
-          <a:lstStyle/>
-          <a:p>
-            <a:pPr indent="0" marL="0">
-              <a:buNone/>
-            </a:pPr>
-            <a:r>
-              <a:rPr lang="en-US" sz="2200" b="1" dirty="0">
+              <a:t>E</a:t>
+            </a:r>
+            <a:endParaRPr lang="en-US" sz="1200" dirty="0"/>
+          </a:p>
+        </p:txBody>
+      </p:sp>
+      <p:sp>
+        <p:nvSpPr>
+          <p:cNvPr id="16" name="Text 13"/>
+          <p:cNvSpPr/>
+          <p:nvPr/>
+        </p:nvSpPr>
+        <p:spPr>
+          <a:xfrm>
+            <a:off x="5120640" y="4526280"/>
+            <a:ext cx="6583680" cy="502920"/>
+          </a:xfrm>
+          <a:prstGeom prst="rect">
+            <a:avLst/>
+          </a:prstGeom>
+          <a:noFill/>
+          <a:ln/>
+        </p:spPr>
+        <p:txBody>
+          <a:bodyPr wrap="square" lIns="0" tIns="0" rIns="0" bIns="0" rtlCol="0" anchor="ctr"/>
+          <a:lstStyle/>
+          <a:p>
+            <a:pPr indent="0" marL="0">
+              <a:buNone/>
+            </a:pPr>
+            <a:r>
+              <a:rPr lang="en-US" sz="1800" b="1" dirty="0">
                 <a:solidFill>
                   <a:srgbClr val="FFFFFF"/>
                 </a:solidFill>
@@ -7885,93 +7938,93 @@
                 <a:ea typeface="Calibri" pitchFamily="34" charset="-122"/>
                 <a:cs typeface="Calibri" pitchFamily="34" charset="-120"/>
               </a:rPr>
+              <a:t>m.strack@eology.de</a:t>
+            </a:r>
+            <a:endParaRPr lang="en-US" sz="1800" dirty="0"/>
+          </a:p>
+        </p:txBody>
+      </p:sp>
+      <p:sp>
+        <p:nvSpPr>
+          <p:cNvPr id="17" name="Text 14"/>
+          <p:cNvSpPr/>
+          <p:nvPr/>
+        </p:nvSpPr>
+        <p:spPr>
+          <a:xfrm>
+            <a:off x="4754880" y="5029200"/>
+            <a:ext cx="320040" cy="502920"/>
+          </a:xfrm>
+          <a:prstGeom prst="rect">
+            <a:avLst/>
+          </a:prstGeom>
+          <a:noFill/>
+          <a:ln/>
+        </p:spPr>
+        <p:txBody>
+          <a:bodyPr wrap="square" lIns="0" tIns="0" rIns="0" bIns="0" rtlCol="0" anchor="ctr"/>
+          <a:lstStyle/>
+          <a:p>
+            <a:pPr indent="0" marL="0">
+              <a:buNone/>
+            </a:pPr>
+            <a:r>
+              <a:rPr lang="en-US" sz="1200" b="1" dirty="0">
+                <a:solidFill>
+                  <a:srgbClr val="54C7E8"/>
+                </a:solidFill>
+                <a:latin typeface="Calibri" pitchFamily="34" charset="0"/>
+                <a:ea typeface="Calibri" pitchFamily="34" charset="-122"/>
+                <a:cs typeface="Calibri" pitchFamily="34" charset="-120"/>
+              </a:rPr>
+              <a:t>W</a:t>
+            </a:r>
+            <a:endParaRPr lang="en-US" sz="1200" dirty="0"/>
+          </a:p>
+        </p:txBody>
+      </p:sp>
+      <p:sp>
+        <p:nvSpPr>
+          <p:cNvPr id="18" name="Text 15"/>
+          <p:cNvSpPr/>
+          <p:nvPr/>
+        </p:nvSpPr>
+        <p:spPr>
+          <a:xfrm>
+            <a:off x="5120640" y="5029200"/>
+            <a:ext cx="6583680" cy="502920"/>
+          </a:xfrm>
+          <a:prstGeom prst="rect">
+            <a:avLst/>
+          </a:prstGeom>
+          <a:noFill/>
+          <a:ln/>
+        </p:spPr>
+        <p:txBody>
+          <a:bodyPr wrap="square" lIns="0" tIns="0" rIns="0" bIns="0" rtlCol="0" anchor="ctr"/>
+          <a:lstStyle/>
+          <a:p>
+            <a:pPr indent="0" marL="0">
+              <a:buNone/>
+            </a:pPr>
+            <a:r>
+              <a:rPr lang="en-US" sz="1800" b="1" dirty="0">
+                <a:solidFill>
+                  <a:srgbClr val="FFFFFF"/>
+                </a:solidFill>
+                <a:latin typeface="Calibri" pitchFamily="34" charset="0"/>
+                <a:ea typeface="Calibri" pitchFamily="34" charset="-122"/>
+                <a:cs typeface="Calibri" pitchFamily="34" charset="-120"/>
+              </a:rPr>
               <a:t>eology.de</a:t>
             </a:r>
-            <a:endParaRPr lang="en-US" sz="2200" dirty="0"/>
-          </a:p>
-        </p:txBody>
-      </p:sp>
-      <p:sp>
-        <p:nvSpPr>
-          <p:cNvPr id="15" name="Text 13"/>
-          <p:cNvSpPr/>
-          <p:nvPr/>
-        </p:nvSpPr>
-        <p:spPr>
-          <a:xfrm>
-            <a:off x="8138160" y="4389120"/>
-            <a:ext cx="3657600" cy="274320"/>
-          </a:xfrm>
-          <a:prstGeom prst="rect">
-            <a:avLst/>
-          </a:prstGeom>
-          <a:noFill/>
-          <a:ln/>
-        </p:spPr>
-        <p:txBody>
-          <a:bodyPr wrap="square" lIns="0" tIns="0" rIns="0" bIns="0" rtlCol="0" anchor="ctr"/>
-          <a:lstStyle/>
-          <a:p>
-            <a:pPr indent="0" marL="0">
-              <a:buNone/>
-            </a:pPr>
-            <a:r>
-              <a:rPr lang="en-US" sz="1000" b="1" spc="300" kern="0" dirty="0">
-                <a:solidFill>
-                  <a:srgbClr val="54C7E8"/>
-                </a:solidFill>
-                <a:latin typeface="Calibri" pitchFamily="34" charset="0"/>
-                <a:ea typeface="Calibri" pitchFamily="34" charset="-122"/>
-                <a:cs typeface="Calibri" pitchFamily="34" charset="-120"/>
-              </a:rPr>
-              <a:t>STANDORT</a:t>
-            </a:r>
-            <a:endParaRPr lang="en-US" sz="1000" dirty="0"/>
-          </a:p>
-        </p:txBody>
-      </p:sp>
-      <p:sp>
-        <p:nvSpPr>
-          <p:cNvPr id="16" name="Text 14"/>
-          <p:cNvSpPr/>
-          <p:nvPr/>
-        </p:nvSpPr>
-        <p:spPr>
-          <a:xfrm>
-            <a:off x="8138160" y="4663440"/>
-            <a:ext cx="4023360" cy="457200"/>
-          </a:xfrm>
-          <a:prstGeom prst="rect">
-            <a:avLst/>
-          </a:prstGeom>
-          <a:noFill/>
-          <a:ln/>
-        </p:spPr>
-        <p:txBody>
-          <a:bodyPr wrap="square" lIns="0" tIns="0" rIns="0" bIns="0" rtlCol="0" anchor="ctr"/>
-          <a:lstStyle/>
-          <a:p>
-            <a:pPr indent="0" marL="0">
-              <a:buNone/>
-            </a:pPr>
-            <a:r>
-              <a:rPr lang="en-US" sz="1600" b="1" dirty="0">
-                <a:solidFill>
-                  <a:srgbClr val="FFFFFF"/>
-                </a:solidFill>
-                <a:latin typeface="Calibri" pitchFamily="34" charset="0"/>
-                <a:ea typeface="Calibri" pitchFamily="34" charset="-122"/>
-                <a:cs typeface="Calibri" pitchFamily="34" charset="-120"/>
-              </a:rPr>
-              <a:t>Volkach · Würzburg · Hamburg</a:t>
-            </a:r>
-            <a:endParaRPr lang="en-US" sz="1600" dirty="0"/>
-          </a:p>
-        </p:txBody>
-      </p:sp>
-      <p:sp>
-        <p:nvSpPr>
-          <p:cNvPr id="17" name="Shape 15"/>
+            <a:endParaRPr lang="en-US" sz="1800" dirty="0"/>
+          </a:p>
+        </p:txBody>
+      </p:sp>
+      <p:sp>
+        <p:nvSpPr>
+          <p:cNvPr id="19" name="Shape 16"/>
           <p:cNvSpPr/>
           <p:nvPr/>
         </p:nvSpPr>
@@ -7998,7 +8051,7 @@
       </p:sp>
       <p:sp>
         <p:nvSpPr>
-          <p:cNvPr id="18" name="Text 16"/>
+          <p:cNvPr id="20" name="Text 17"/>
           <p:cNvSpPr/>
           <p:nvPr/>
         </p:nvSpPr>

</xml_diff>